<commit_message>
Add yacht-secured loan option alongside portfolio margin loan
Pool 3 now presents two blendable lending levers: the existing
portfolio margin (Lombard) facility at ~30% LTV against Pools 1-2,
plus a new yacht-secured marine mortgage at up to ~50% LTV against
the vessel itself, which frees up portfolio margin headroom.
</commit_message>
<xml_diff>
--- a/Family_Office_Investment_Strategy.pptx
+++ b/Family_Office_Investment_Strategy.pptx
@@ -11486,7 +11486,7 @@
                 <a:ea typeface="Calibri" pitchFamily="34" charset="-122"/>
                 <a:cs typeface="Calibri" pitchFamily="34" charset="-120"/>
               </a:rPr>
-              <a:t>Fund the yacht purchase and its ongoing running costs through a lending facility, preserving Pools 1 and 2 to keep compounding uninterrupted.</a:t>
+              <a:t>Fund the yacht purchase and its ongoing running costs by blending two lending levers, preserving Pools 1 and 2 to keep compounding uninterrupted.</a:t>
             </a:r>
             <a:endParaRPr lang="en-US" sz="1300" dirty="0"/>
           </a:p>
@@ -11501,7 +11501,7 @@
         <p:spPr>
           <a:xfrm>
             <a:off x="457200" y="2788920"/>
-            <a:ext cx="6035040" cy="3200400"/>
+            <a:ext cx="6035040" cy="3291840"/>
           </a:xfrm>
           <a:prstGeom prst="rect">
             <a:avLst/>
@@ -11532,7 +11532,7 @@
                 <a:ea typeface="Calibri" pitchFamily="34" charset="-122"/>
                 <a:cs typeface="Calibri" pitchFamily="34" charset="-120"/>
               </a:rPr>
-              <a:t>Securities-backed (Lombard) lending facility collateralised against Pools 1–2 and the liquidity reserve</a:t>
+              <a:t>Fund the purchase by blending two lending levers rather than drawing on a single source</a:t>
             </a:r>
             <a:endParaRPr lang="en-US" sz="1250" dirty="0"/>
           </a:p>
@@ -11556,7 +11556,7 @@
                 <a:ea typeface="Calibri" pitchFamily="34" charset="-122"/>
                 <a:cs typeface="Calibri" pitchFamily="34" charset="-120"/>
               </a:rPr>
-              <a:t>Solve for a loan-to-value that keeps the facility comfortably serviceable from portfolio yield alone</a:t>
+              <a:t>Portfolio margin (Lombard) facility collateralised against Pools 1–2 and the liquidity reserve, typically ~30% LTV</a:t>
             </a:r>
             <a:endParaRPr lang="en-US" sz="1250" dirty="0"/>
           </a:p>
@@ -11580,7 +11580,7 @@
                 <a:ea typeface="Calibri" pitchFamily="34" charset="-122"/>
                 <a:cs typeface="Calibri" pitchFamily="34" charset="-120"/>
               </a:rPr>
-              <a:t>Purchase drawn as a term facility; running costs drawn as a revolving line, not funded from capital</a:t>
+              <a:t>Marine mortgage collateralised directly against the vessel itself, available up to ~50% LTV — freeing up portfolio margin headroom</a:t>
             </a:r>
             <a:endParaRPr lang="en-US" sz="1250" dirty="0"/>
           </a:p>
@@ -11604,7 +11604,7 @@
                 <a:ea typeface="Calibri" pitchFamily="34" charset="-122"/>
                 <a:cs typeface="Calibri" pitchFamily="34" charset="-120"/>
               </a:rPr>
-              <a:t>Interest-rate hedge reviewed alongside covenant headroom at each Investment Committee meeting</a:t>
+              <a:t>Running costs (crew, maintenance, insurance, berthing), roughly 10% of vessel value p.a., drawn as a revolving line, never funded from core capital</a:t>
             </a:r>
             <a:endParaRPr lang="en-US" sz="1250" dirty="0"/>
           </a:p>
@@ -11628,7 +11628,7 @@
                 <a:ea typeface="Calibri" pitchFamily="34" charset="-122"/>
                 <a:cs typeface="Calibri" pitchFamily="34" charset="-120"/>
               </a:rPr>
-              <a:t>No forced sale of core holdings to fund acquisition, crew, maintenance, insurance or berthing</a:t>
+              <a:t>Blend, rate hedge and covenant headroom across both facilities reviewed at each Investment Committee meeting</a:t>
             </a:r>
             <a:endParaRPr lang="en-US" sz="1250" dirty="0"/>
           </a:p>
@@ -11735,7 +11735,7 @@
                 <a:ea typeface="Calibri" pitchFamily="34" charset="-122"/>
                 <a:cs typeface="Calibri" pitchFamily="34" charset="-120"/>
               </a:rPr>
-              <a:t>Target loan-to-value</a:t>
+              <a:t>Portfolio margin loan LTV</a:t>
             </a:r>
             <a:endParaRPr lang="en-US" sz="1050" dirty="0"/>
           </a:p>
@@ -11803,7 +11803,7 @@
                 <a:ea typeface="Cambria" pitchFamily="34" charset="-122"/>
                 <a:cs typeface="Cambria" pitchFamily="34" charset="-120"/>
               </a:rPr>
-              <a:t>~10%</a:t>
+              <a:t>~50%</a:t>
             </a:r>
             <a:endParaRPr lang="en-US" sz="2600" dirty="0"/>
           </a:p>
@@ -11842,7 +11842,7 @@
                 <a:ea typeface="Calibri" pitchFamily="34" charset="-122"/>
                 <a:cs typeface="Calibri" pitchFamily="34" charset="-120"/>
               </a:rPr>
-              <a:t>Running cost, % of vessel value p.a.</a:t>
+              <a:t>Yacht-secured loan LTV</a:t>
             </a:r>
             <a:endParaRPr lang="en-US" sz="1050" dirty="0"/>
           </a:p>
@@ -11856,12 +11856,12 @@
         </p:nvSpPr>
         <p:spPr>
           <a:xfrm>
-            <a:off x="6903720" y="3246120"/>
-            <a:ext cx="4800600" cy="2743200"/>
+            <a:off x="6903720" y="3108960"/>
+            <a:ext cx="4800600" cy="3291840"/>
           </a:xfrm>
           <a:prstGeom prst="roundRect">
             <a:avLst>
-              <a:gd name="adj" fmla="val 2667"/>
+              <a:gd name="adj" fmla="val 2222"/>
             </a:avLst>
           </a:prstGeom>
           <a:solidFill>
@@ -11890,8 +11890,8 @@
         </p:nvSpPr>
         <p:spPr>
           <a:xfrm>
-            <a:off x="7132320" y="3429000"/>
-            <a:ext cx="4343400" cy="274320"/>
+            <a:off x="7159752" y="3273552"/>
+            <a:ext cx="4288536" cy="274320"/>
           </a:xfrm>
           <a:prstGeom prst="rect">
             <a:avLst/>
@@ -11915,7 +11915,7 @@
                 <a:ea typeface="Cambria" pitchFamily="34" charset="-122"/>
                 <a:cs typeface="Cambria" pitchFamily="34" charset="-120"/>
               </a:rPr>
-              <a:t>How the facility is structured</a:t>
+              <a:t>Two lending levers, blended</a:t>
             </a:r>
             <a:endParaRPr lang="en-US" sz="1250" dirty="0"/>
           </a:p>
@@ -11929,12 +11929,74 @@
         </p:nvSpPr>
         <p:spPr>
           <a:xfrm>
-            <a:off x="7132320" y="3931920"/>
-            <a:ext cx="1325880" cy="1005840"/>
+            <a:off x="7159752" y="3648456"/>
+            <a:ext cx="146304" cy="146304"/>
+          </a:xfrm>
+          <a:prstGeom prst="ellipse">
+            <a:avLst/>
+          </a:prstGeom>
+          <a:solidFill>
+            <a:srgbClr val="C6A15B"/>
+          </a:solidFill>
+          <a:ln/>
+        </p:spPr>
+      </p:sp>
+      <p:sp>
+        <p:nvSpPr>
+          <p:cNvPr id="19" name="Text 16"/>
+          <p:cNvSpPr txBox="1"/>
+          <p:nvPr/>
+        </p:nvSpPr>
+        <p:spPr>
+          <a:xfrm>
+            <a:off x="7434072" y="3547872"/>
+            <a:ext cx="3246120" cy="457200"/>
+          </a:xfrm>
+          <a:prstGeom prst="rect">
+            <a:avLst/>
+          </a:prstGeom>
+          <a:noFill/>
+          <a:ln/>
+        </p:spPr>
+        <p:txBody>
+          <a:bodyPr wrap="square" lIns="0" tIns="0" rIns="0" bIns="0" rtlCol="0" anchor="ctr"/>
+          <a:lstStyle/>
+          <a:p>
+            <a:pPr indent="0" marL="0">
+              <a:lnSpc>
+                <a:spcPct val="105000"/>
+              </a:lnSpc>
+              <a:buNone/>
+            </a:pPr>
+            <a:r>
+              <a:rPr lang="en-US" sz="1150" b="1" dirty="0">
+                <a:solidFill>
+                  <a:srgbClr val="0B1B2B"/>
+                </a:solidFill>
+                <a:latin typeface="Calibri" pitchFamily="34" charset="0"/>
+                <a:ea typeface="Calibri" pitchFamily="34" charset="-122"/>
+                <a:cs typeface="Calibri" pitchFamily="34" charset="-120"/>
+              </a:rPr>
+              <a:t>Portfolio Margin Loan</a:t>
+            </a:r>
+            <a:endParaRPr lang="en-US" sz="1150" dirty="0"/>
+          </a:p>
+        </p:txBody>
+      </p:sp>
+      <p:sp>
+        <p:nvSpPr>
+          <p:cNvPr id="20" name="Shape 17"/>
+          <p:cNvSpPr/>
+          <p:nvPr/>
+        </p:nvSpPr>
+        <p:spPr>
+          <a:xfrm>
+            <a:off x="10469880" y="3547872"/>
+            <a:ext cx="1005840" cy="274320"/>
           </a:xfrm>
           <a:prstGeom prst="roundRect">
             <a:avLst>
-              <a:gd name="adj" fmla="val 6364"/>
+              <a:gd name="adj" fmla="val 50000"/>
             </a:avLst>
           </a:prstGeom>
           <a:solidFill>
@@ -11945,14 +12007,14 @@
       </p:sp>
       <p:sp>
         <p:nvSpPr>
-          <p:cNvPr id="19" name="Text 16"/>
-          <p:cNvSpPr txBox="1"/>
-          <p:nvPr/>
-        </p:nvSpPr>
-        <p:spPr>
-          <a:xfrm>
-            <a:off x="7187184" y="4023360"/>
-            <a:ext cx="1216152" cy="292608"/>
+          <p:cNvPr id="21" name="Text 18"/>
+          <p:cNvSpPr txBox="1"/>
+          <p:nvPr/>
+        </p:nvSpPr>
+        <p:spPr>
+          <a:xfrm>
+            <a:off x="10469880" y="3547872"/>
+            <a:ext cx="1005840" cy="274320"/>
           </a:xfrm>
           <a:prstGeom prst="rect">
             <a:avLst/>
@@ -11968,30 +12030,30 @@
               <a:buNone/>
             </a:pPr>
             <a:r>
-              <a:rPr lang="en-US" sz="1050" b="1" dirty="0">
-                <a:solidFill>
-                  <a:srgbClr val="FFFFFF"/>
+              <a:rPr lang="en-US" sz="950" b="1" dirty="0">
+                <a:solidFill>
+                  <a:srgbClr val="C6A15B"/>
                 </a:solidFill>
                 <a:latin typeface="Calibri" pitchFamily="34" charset="0"/>
                 <a:ea typeface="Calibri" pitchFamily="34" charset="-122"/>
                 <a:cs typeface="Calibri" pitchFamily="34" charset="-120"/>
               </a:rPr>
-              <a:t>Collateral</a:t>
-            </a:r>
-            <a:endParaRPr lang="en-US" sz="1050" dirty="0"/>
-          </a:p>
-        </p:txBody>
-      </p:sp>
-      <p:sp>
-        <p:nvSpPr>
-          <p:cNvPr id="20" name="Text 17"/>
-          <p:cNvSpPr txBox="1"/>
-          <p:nvPr/>
-        </p:nvSpPr>
-        <p:spPr>
-          <a:xfrm>
-            <a:off x="7187184" y="4315968"/>
-            <a:ext cx="1216152" cy="548640"/>
+              <a:t>~30% LTV</a:t>
+            </a:r>
+            <a:endParaRPr lang="en-US" sz="950" dirty="0"/>
+          </a:p>
+        </p:txBody>
+      </p:sp>
+      <p:sp>
+        <p:nvSpPr>
+          <p:cNvPr id="22" name="Text 19"/>
+          <p:cNvSpPr txBox="1"/>
+          <p:nvPr/>
+        </p:nvSpPr>
+        <p:spPr>
+          <a:xfrm>
+            <a:off x="7434072" y="3840480"/>
+            <a:ext cx="4014216" cy="457200"/>
           </a:xfrm>
           <a:prstGeom prst="rect">
             <a:avLst/>
@@ -12003,103 +12065,141 @@
           <a:bodyPr wrap="square" rtlCol="0" anchor="ctr"/>
           <a:lstStyle/>
           <a:p>
-            <a:pPr algn="ctr" indent="0" marL="0">
+            <a:pPr indent="0" marL="0">
+              <a:lnSpc>
+                <a:spcPct val="112000"/>
+              </a:lnSpc>
+              <a:buNone/>
+            </a:pPr>
+            <a:r>
+              <a:rPr lang="en-US" sz="1000" dirty="0">
+                <a:solidFill>
+                  <a:srgbClr val="8C93A0"/>
+                </a:solidFill>
+                <a:latin typeface="Calibri" pitchFamily="34" charset="0"/>
+                <a:ea typeface="Calibri" pitchFamily="34" charset="-122"/>
+                <a:cs typeface="Calibri" pitchFamily="34" charset="-120"/>
+              </a:rPr>
+              <a:t>Collateralised against Pools 1–2; lower cost, broad flexibility</a:t>
+            </a:r>
+            <a:endParaRPr lang="en-US" sz="1000" dirty="0"/>
+          </a:p>
+        </p:txBody>
+      </p:sp>
+      <p:sp>
+        <p:nvSpPr>
+          <p:cNvPr id="23" name="Shape 20"/>
+          <p:cNvSpPr/>
+          <p:nvPr/>
+        </p:nvSpPr>
+        <p:spPr>
+          <a:xfrm>
+            <a:off x="7159752" y="4425696"/>
+            <a:ext cx="146304" cy="146304"/>
+          </a:xfrm>
+          <a:prstGeom prst="ellipse">
+            <a:avLst/>
+          </a:prstGeom>
+          <a:solidFill>
+            <a:srgbClr val="C6A15B"/>
+          </a:solidFill>
+          <a:ln/>
+        </p:spPr>
+      </p:sp>
+      <p:sp>
+        <p:nvSpPr>
+          <p:cNvPr id="24" name="Text 21"/>
+          <p:cNvSpPr txBox="1"/>
+          <p:nvPr/>
+        </p:nvSpPr>
+        <p:spPr>
+          <a:xfrm>
+            <a:off x="7434072" y="4325112"/>
+            <a:ext cx="3246120" cy="457200"/>
+          </a:xfrm>
+          <a:prstGeom prst="rect">
+            <a:avLst/>
+          </a:prstGeom>
+          <a:noFill/>
+          <a:ln/>
+        </p:spPr>
+        <p:txBody>
+          <a:bodyPr wrap="square" lIns="0" tIns="0" rIns="0" bIns="0" rtlCol="0" anchor="ctr"/>
+          <a:lstStyle/>
+          <a:p>
+            <a:pPr indent="0" marL="0">
               <a:lnSpc>
                 <a:spcPct val="105000"/>
               </a:lnSpc>
               <a:buNone/>
             </a:pPr>
             <a:r>
-              <a:rPr lang="en-US" sz="880" dirty="0">
-                <a:solidFill>
-                  <a:srgbClr val="F6F3EC"/>
+              <a:rPr lang="en-US" sz="1150" b="1" dirty="0">
+                <a:solidFill>
+                  <a:srgbClr val="0B1B2B"/>
                 </a:solidFill>
                 <a:latin typeface="Calibri" pitchFamily="34" charset="0"/>
                 <a:ea typeface="Calibri" pitchFamily="34" charset="-122"/>
                 <a:cs typeface="Calibri" pitchFamily="34" charset="-120"/>
               </a:rPr>
-              <a:t>Pools 1–2 +</a:t>
-            </a:r>
-            <a:endParaRPr lang="en-US" sz="880" dirty="0"/>
-          </a:p>
-          <a:p>
-            <a:pPr algn="ctr" indent="0" marL="0">
+              <a:t>Yacht-Secured Loan</a:t>
+            </a:r>
+            <a:endParaRPr lang="en-US" sz="1150" dirty="0"/>
+          </a:p>
+          <a:p>
+            <a:pPr indent="0" marL="0">
               <a:lnSpc>
                 <a:spcPct val="105000"/>
               </a:lnSpc>
               <a:buNone/>
             </a:pPr>
             <a:r>
-              <a:rPr lang="en-US" sz="880" dirty="0">
-                <a:solidFill>
-                  <a:srgbClr val="F6F3EC"/>
+              <a:rPr lang="en-US" sz="1150" b="1" dirty="0">
+                <a:solidFill>
+                  <a:srgbClr val="0B1B2B"/>
                 </a:solidFill>
                 <a:latin typeface="Calibri" pitchFamily="34" charset="0"/>
                 <a:ea typeface="Calibri" pitchFamily="34" charset="-122"/>
                 <a:cs typeface="Calibri" pitchFamily="34" charset="-120"/>
               </a:rPr>
-              <a:t>liquidity reserve</a:t>
-            </a:r>
-            <a:endParaRPr lang="en-US" sz="880" dirty="0"/>
-          </a:p>
-        </p:txBody>
-      </p:sp>
-      <p:sp>
-        <p:nvSpPr>
-          <p:cNvPr id="21" name="Shape 18"/>
+              <a:t>(Marine Mortgage)</a:t>
+            </a:r>
+            <a:endParaRPr lang="en-US" sz="1150" dirty="0"/>
+          </a:p>
+        </p:txBody>
+      </p:sp>
+      <p:sp>
+        <p:nvSpPr>
+          <p:cNvPr id="25" name="Shape 22"/>
           <p:cNvSpPr/>
           <p:nvPr/>
         </p:nvSpPr>
         <p:spPr>
           <a:xfrm>
-            <a:off x="8458200" y="4434840"/>
-            <a:ext cx="182880" cy="0"/>
-          </a:xfrm>
-          <a:prstGeom prst="line">
-            <a:avLst/>
-          </a:prstGeom>
-          <a:noFill/>
-          <a:ln w="22225">
-            <a:solidFill>
-              <a:srgbClr val="C6A15B"/>
-            </a:solidFill>
-            <a:prstDash val="solid"/>
-            <a:tailEnd type="triangle"/>
-          </a:ln>
-        </p:spPr>
-      </p:sp>
-      <p:sp>
-        <p:nvSpPr>
-          <p:cNvPr id="22" name="Shape 19"/>
-          <p:cNvSpPr/>
-          <p:nvPr/>
-        </p:nvSpPr>
-        <p:spPr>
-          <a:xfrm>
-            <a:off x="8641080" y="3931920"/>
-            <a:ext cx="1325880" cy="1005840"/>
+            <a:off x="10469880" y="4325112"/>
+            <a:ext cx="1005840" cy="274320"/>
           </a:xfrm>
           <a:prstGeom prst="roundRect">
             <a:avLst>
-              <a:gd name="adj" fmla="val 6364"/>
+              <a:gd name="adj" fmla="val 50000"/>
             </a:avLst>
           </a:prstGeom>
           <a:solidFill>
-            <a:srgbClr val="C6A15B"/>
+            <a:srgbClr val="0B1B2B"/>
           </a:solidFill>
           <a:ln/>
         </p:spPr>
       </p:sp>
       <p:sp>
         <p:nvSpPr>
-          <p:cNvPr id="23" name="Text 20"/>
-          <p:cNvSpPr txBox="1"/>
-          <p:nvPr/>
-        </p:nvSpPr>
-        <p:spPr>
-          <a:xfrm>
-            <a:off x="8695944" y="4023360"/>
-            <a:ext cx="1216152" cy="292608"/>
+          <p:cNvPr id="26" name="Text 23"/>
+          <p:cNvSpPr txBox="1"/>
+          <p:nvPr/>
+        </p:nvSpPr>
+        <p:spPr>
+          <a:xfrm>
+            <a:off x="10469880" y="4325112"/>
+            <a:ext cx="1005840" cy="274320"/>
           </a:xfrm>
           <a:prstGeom prst="rect">
             <a:avLst/>
@@ -12115,30 +12215,30 @@
               <a:buNone/>
             </a:pPr>
             <a:r>
-              <a:rPr lang="en-US" sz="1050" b="1" dirty="0">
-                <a:solidFill>
-                  <a:srgbClr val="0B1B2B"/>
+              <a:rPr lang="en-US" sz="950" b="1" dirty="0">
+                <a:solidFill>
+                  <a:srgbClr val="C6A15B"/>
                 </a:solidFill>
                 <a:latin typeface="Calibri" pitchFamily="34" charset="0"/>
                 <a:ea typeface="Calibri" pitchFamily="34" charset="-122"/>
                 <a:cs typeface="Calibri" pitchFamily="34" charset="-120"/>
               </a:rPr>
-              <a:t>Lending Facility</a:t>
-            </a:r>
-            <a:endParaRPr lang="en-US" sz="1050" dirty="0"/>
-          </a:p>
-        </p:txBody>
-      </p:sp>
-      <p:sp>
-        <p:nvSpPr>
-          <p:cNvPr id="24" name="Text 21"/>
-          <p:cNvSpPr txBox="1"/>
-          <p:nvPr/>
-        </p:nvSpPr>
-        <p:spPr>
-          <a:xfrm>
-            <a:off x="8695944" y="4315968"/>
-            <a:ext cx="1216152" cy="548640"/>
+              <a:t>~50% LTV</a:t>
+            </a:r>
+            <a:endParaRPr lang="en-US" sz="950" dirty="0"/>
+          </a:p>
+        </p:txBody>
+      </p:sp>
+      <p:sp>
+        <p:nvSpPr>
+          <p:cNvPr id="27" name="Text 24"/>
+          <p:cNvSpPr txBox="1"/>
+          <p:nvPr/>
+        </p:nvSpPr>
+        <p:spPr>
+          <a:xfrm>
+            <a:off x="7434072" y="4800600"/>
+            <a:ext cx="4014216" cy="457200"/>
           </a:xfrm>
           <a:prstGeom prst="rect">
             <a:avLst/>
@@ -12150,233 +12250,89 @@
           <a:bodyPr wrap="square" rtlCol="0" anchor="ctr"/>
           <a:lstStyle/>
           <a:p>
-            <a:pPr algn="ctr" indent="0" marL="0">
+            <a:pPr indent="0" marL="0">
               <a:lnSpc>
-                <a:spcPct val="105000"/>
+                <a:spcPct val="112000"/>
               </a:lnSpc>
               <a:buNone/>
             </a:pPr>
             <a:r>
-              <a:rPr lang="en-US" sz="880" dirty="0">
-                <a:solidFill>
-                  <a:srgbClr val="0B1B2B"/>
+              <a:rPr lang="en-US" sz="1000" dirty="0">
+                <a:solidFill>
+                  <a:srgbClr val="8C93A0"/>
                 </a:solidFill>
                 <a:latin typeface="Calibri" pitchFamily="34" charset="0"/>
                 <a:ea typeface="Calibri" pitchFamily="34" charset="-122"/>
                 <a:cs typeface="Calibri" pitchFamily="34" charset="-120"/>
               </a:rPr>
-              <a:t>~30% LTV,</a:t>
-            </a:r>
-            <a:endParaRPr lang="en-US" sz="880" dirty="0"/>
-          </a:p>
-          <a:p>
-            <a:pPr algn="ctr" indent="0" marL="0">
+              <a:t>Collateralised against the vessel itself; frees portfolio margin headroom</a:t>
+            </a:r>
+            <a:endParaRPr lang="en-US" sz="1000" dirty="0"/>
+          </a:p>
+        </p:txBody>
+      </p:sp>
+      <p:sp>
+        <p:nvSpPr>
+          <p:cNvPr id="28" name="Shape 25"/>
+          <p:cNvSpPr/>
+          <p:nvPr/>
+        </p:nvSpPr>
+        <p:spPr>
+          <a:xfrm>
+            <a:off x="7159752" y="5285232"/>
+            <a:ext cx="4288536" cy="0"/>
+          </a:xfrm>
+          <a:prstGeom prst="line">
+            <a:avLst/>
+          </a:prstGeom>
+          <a:noFill/>
+          <a:ln w="12700">
+            <a:solidFill>
+              <a:srgbClr val="E3DFD3"/>
+            </a:solidFill>
+            <a:prstDash val="solid"/>
+          </a:ln>
+        </p:spPr>
+      </p:sp>
+      <p:sp>
+        <p:nvSpPr>
+          <p:cNvPr id="29" name="Text 26"/>
+          <p:cNvSpPr txBox="1"/>
+          <p:nvPr/>
+        </p:nvSpPr>
+        <p:spPr>
+          <a:xfrm>
+            <a:off x="7159752" y="5413248"/>
+            <a:ext cx="4288536" cy="777240"/>
+          </a:xfrm>
+          <a:prstGeom prst="rect">
+            <a:avLst/>
+          </a:prstGeom>
+          <a:noFill/>
+          <a:ln/>
+        </p:spPr>
+        <p:txBody>
+          <a:bodyPr wrap="square" lIns="0" tIns="0" rIns="0" bIns="0" rtlCol="0" anchor="ctr"/>
+          <a:lstStyle/>
+          <a:p>
+            <a:pPr indent="0" marL="0">
               <a:lnSpc>
-                <a:spcPct val="105000"/>
+                <a:spcPct val="118000"/>
               </a:lnSpc>
               <a:buNone/>
             </a:pPr>
             <a:r>
-              <a:rPr lang="en-US" sz="880" dirty="0">
-                <a:solidFill>
-                  <a:srgbClr val="0B1B2B"/>
+              <a:rPr lang="en-US" sz="950" i="1" dirty="0">
+                <a:solidFill>
+                  <a:srgbClr val="8C93A0"/>
                 </a:solidFill>
                 <a:latin typeface="Calibri" pitchFamily="34" charset="0"/>
                 <a:ea typeface="Calibri" pitchFamily="34" charset="-122"/>
                 <a:cs typeface="Calibri" pitchFamily="34" charset="-120"/>
               </a:rPr>
-              <a:t>yield-serviced</a:t>
-            </a:r>
-            <a:endParaRPr lang="en-US" sz="880" dirty="0"/>
-          </a:p>
-        </p:txBody>
-      </p:sp>
-      <p:sp>
-        <p:nvSpPr>
-          <p:cNvPr id="25" name="Shape 22"/>
-          <p:cNvSpPr/>
-          <p:nvPr/>
-        </p:nvSpPr>
-        <p:spPr>
-          <a:xfrm>
-            <a:off x="9966960" y="4434840"/>
-            <a:ext cx="182880" cy="0"/>
-          </a:xfrm>
-          <a:prstGeom prst="line">
-            <a:avLst/>
-          </a:prstGeom>
-          <a:noFill/>
-          <a:ln w="22225">
-            <a:solidFill>
-              <a:srgbClr val="C6A15B"/>
-            </a:solidFill>
-            <a:prstDash val="solid"/>
-            <a:tailEnd type="triangle"/>
-          </a:ln>
-        </p:spPr>
-      </p:sp>
-      <p:sp>
-        <p:nvSpPr>
-          <p:cNvPr id="26" name="Shape 23"/>
-          <p:cNvSpPr/>
-          <p:nvPr/>
-        </p:nvSpPr>
-        <p:spPr>
-          <a:xfrm>
-            <a:off x="10149840" y="3931920"/>
-            <a:ext cx="1325880" cy="1005840"/>
-          </a:xfrm>
-          <a:prstGeom prst="roundRect">
-            <a:avLst>
-              <a:gd name="adj" fmla="val 6364"/>
-            </a:avLst>
-          </a:prstGeom>
-          <a:solidFill>
-            <a:srgbClr val="0B1B2B"/>
-          </a:solidFill>
-          <a:ln/>
-        </p:spPr>
-      </p:sp>
-      <p:sp>
-        <p:nvSpPr>
-          <p:cNvPr id="27" name="Text 24"/>
-          <p:cNvSpPr txBox="1"/>
-          <p:nvPr/>
-        </p:nvSpPr>
-        <p:spPr>
-          <a:xfrm>
-            <a:off x="10204704" y="4023360"/>
-            <a:ext cx="1216152" cy="292608"/>
-          </a:xfrm>
-          <a:prstGeom prst="rect">
-            <a:avLst/>
-          </a:prstGeom>
-          <a:noFill/>
-          <a:ln/>
-        </p:spPr>
-        <p:txBody>
-          <a:bodyPr wrap="square" rtlCol="0" anchor="ctr"/>
-          <a:lstStyle/>
-          <a:p>
-            <a:pPr algn="ctr" indent="0" marL="0">
-              <a:buNone/>
-            </a:pPr>
-            <a:r>
-              <a:rPr lang="en-US" sz="1050" b="1" dirty="0">
-                <a:solidFill>
-                  <a:srgbClr val="FFFFFF"/>
-                </a:solidFill>
-                <a:latin typeface="Calibri" pitchFamily="34" charset="0"/>
-                <a:ea typeface="Calibri" pitchFamily="34" charset="-122"/>
-                <a:cs typeface="Calibri" pitchFamily="34" charset="-120"/>
-              </a:rPr>
-              <a:t>Yacht</a:t>
-            </a:r>
-            <a:endParaRPr lang="en-US" sz="1050" dirty="0"/>
-          </a:p>
-        </p:txBody>
-      </p:sp>
-      <p:sp>
-        <p:nvSpPr>
-          <p:cNvPr id="28" name="Text 25"/>
-          <p:cNvSpPr txBox="1"/>
-          <p:nvPr/>
-        </p:nvSpPr>
-        <p:spPr>
-          <a:xfrm>
-            <a:off x="10204704" y="4315968"/>
-            <a:ext cx="1216152" cy="548640"/>
-          </a:xfrm>
-          <a:prstGeom prst="rect">
-            <a:avLst/>
-          </a:prstGeom>
-          <a:noFill/>
-          <a:ln/>
-        </p:spPr>
-        <p:txBody>
-          <a:bodyPr wrap="square" rtlCol="0" anchor="ctr"/>
-          <a:lstStyle/>
-          <a:p>
-            <a:pPr algn="ctr" indent="0" marL="0">
-              <a:lnSpc>
-                <a:spcPct val="105000"/>
-              </a:lnSpc>
-              <a:buNone/>
-            </a:pPr>
-            <a:r>
-              <a:rPr lang="en-US" sz="880" dirty="0">
-                <a:solidFill>
-                  <a:srgbClr val="F6F3EC"/>
-                </a:solidFill>
-                <a:latin typeface="Calibri" pitchFamily="34" charset="0"/>
-                <a:ea typeface="Calibri" pitchFamily="34" charset="-122"/>
-                <a:cs typeface="Calibri" pitchFamily="34" charset="-120"/>
-              </a:rPr>
-              <a:t>Purchase +</a:t>
-            </a:r>
-            <a:endParaRPr lang="en-US" sz="880" dirty="0"/>
-          </a:p>
-          <a:p>
-            <a:pPr algn="ctr" indent="0" marL="0">
-              <a:lnSpc>
-                <a:spcPct val="105000"/>
-              </a:lnSpc>
-              <a:buNone/>
-            </a:pPr>
-            <a:r>
-              <a:rPr lang="en-US" sz="880" dirty="0">
-                <a:solidFill>
-                  <a:srgbClr val="F6F3EC"/>
-                </a:solidFill>
-                <a:latin typeface="Calibri" pitchFamily="34" charset="0"/>
-                <a:ea typeface="Calibri" pitchFamily="34" charset="-122"/>
-                <a:cs typeface="Calibri" pitchFamily="34" charset="-120"/>
-              </a:rPr>
-              <a:t>running costs</a:t>
-            </a:r>
-            <a:endParaRPr lang="en-US" sz="880" dirty="0"/>
-          </a:p>
-        </p:txBody>
-      </p:sp>
-      <p:sp>
-        <p:nvSpPr>
-          <p:cNvPr id="29" name="Text 26"/>
-          <p:cNvSpPr txBox="1"/>
-          <p:nvPr/>
-        </p:nvSpPr>
-        <p:spPr>
-          <a:xfrm>
-            <a:off x="7132320" y="5193792"/>
-            <a:ext cx="4343400" cy="457200"/>
-          </a:xfrm>
-          <a:prstGeom prst="rect">
-            <a:avLst/>
-          </a:prstGeom>
-          <a:noFill/>
-          <a:ln/>
-        </p:spPr>
-        <p:txBody>
-          <a:bodyPr wrap="square" rtlCol="0" anchor="ctr"/>
-          <a:lstStyle/>
-          <a:p>
-            <a:pPr algn="ctr" indent="0" marL="0">
-              <a:lnSpc>
-                <a:spcPct val="115000"/>
-              </a:lnSpc>
-              <a:buNone/>
-            </a:pPr>
-            <a:r>
-              <a:rPr lang="en-US" sz="1000" i="1" dirty="0">
-                <a:solidFill>
-                  <a:srgbClr val="8C93A0"/>
-                </a:solidFill>
-                <a:latin typeface="Calibri" pitchFamily="34" charset="0"/>
-                <a:ea typeface="Calibri" pitchFamily="34" charset="-122"/>
-                <a:cs typeface="Calibri" pitchFamily="34" charset="-120"/>
-              </a:rPr>
-              <a:t>Interest and running costs serviced from Pool 2 income — core capital is never drawn down.</a:t>
-            </a:r>
-            <a:endParaRPr lang="en-US" sz="1000" dirty="0"/>
+              <a:t>Both facilities can be drawn together — the marine mortgage funds the bulk of the purchase at the higher LTV, with the portfolio margin line as a flexible top-up. Interest and running costs are serviced from Pool 2 income; core capital is never drawn down.</a:t>
+            </a:r>
+            <a:endParaRPr lang="en-US" sz="950" dirty="0"/>
           </a:p>
         </p:txBody>
       </p:sp>

</xml_diff>

<commit_message>
Decouple Pool 3 from Pool 2 and solve Pool 2 asset mix for 7.5%
Pool 3 (yacht) running costs are now funded by its own dedicated
$30m portfolio targeting 6% p.a., rather than Pool 2 income. Pool 2
is redefined as 3% distributed yield + 4.5% capital growth = 7.5%
total, with an asset allocation (50% equities / 20% bonds & credit /
20% alternatives / 10% liquidity) solved against illustrative
long-run return and yield assumptions to hit that target. Updates
the allocation footnote, five-pools summary card, and governance
table to match.
</commit_message>
<xml_diff>
--- a/Family_Office_Investment_Strategy.pptx
+++ b/Family_Office_Investment_Strategy.pptx
@@ -478,7 +478,7 @@
               <c:strCache>
                 <c:ptCount val="1"/>
                 <c:pt idx="0">
-                  <c:v>Income</c:v>
+                  <c:v>Distributed</c:v>
                 </c:pt>
               </c:strCache>
             </c:strRef>
@@ -535,7 +535,7 @@
                 <c:formatCode>General</c:formatCode>
                 <c:ptCount val="1"/>
                 <c:pt idx="0">
-                  <c:v>4</c:v>
+                  <c:v>3</c:v>
                 </c:pt>
               </c:numCache>
             </c:numRef>
@@ -607,7 +607,7 @@
                 <c:formatCode>General</c:formatCode>
                 <c:ptCount val="1"/>
                 <c:pt idx="0">
-                  <c:v>3.5</c:v>
+                  <c:v>4.5</c:v>
                 </c:pt>
               </c:numCache>
             </c:numRef>
@@ -798,7 +798,7 @@
               <c:strCache>
                 <c:ptCount val="1"/>
                 <c:pt idx="0">
-                  <c:v>Global Equities</c:v>
+                  <c:v>Equities</c:v>
                 </c:pt>
               </c:strCache>
             </c:strRef>
@@ -855,7 +855,7 @@
                 <c:formatCode>General</c:formatCode>
                 <c:ptCount val="1"/>
                 <c:pt idx="0">
-                  <c:v>40</c:v>
+                  <c:v>50</c:v>
                 </c:pt>
               </c:numCache>
             </c:numRef>
@@ -870,7 +870,7 @@
               <c:strCache>
                 <c:ptCount val="1"/>
                 <c:pt idx="0">
-                  <c:v>Fixed Income &amp; Credit</c:v>
+                  <c:v>Bonds &amp; Credit</c:v>
                 </c:pt>
               </c:strCache>
             </c:strRef>
@@ -927,7 +927,7 @@
                 <c:formatCode>General</c:formatCode>
                 <c:ptCount val="1"/>
                 <c:pt idx="0">
-                  <c:v>35</c:v>
+                  <c:v>20</c:v>
                 </c:pt>
               </c:numCache>
             </c:numRef>
@@ -942,7 +942,7 @@
               <c:strCache>
                 <c:ptCount val="1"/>
                 <c:pt idx="0">
-                  <c:v>Real Assets</c:v>
+                  <c:v>Alternatives</c:v>
                 </c:pt>
               </c:strCache>
             </c:strRef>
@@ -999,7 +999,7 @@
                 <c:formatCode>General</c:formatCode>
                 <c:ptCount val="1"/>
                 <c:pt idx="0">
-                  <c:v>10</c:v>
+                  <c:v>20</c:v>
                 </c:pt>
               </c:numCache>
             </c:numRef>
@@ -1014,79 +1014,7 @@
               <c:strCache>
                 <c:ptCount val="1"/>
                 <c:pt idx="0">
-                  <c:v>Alternatives</c:v>
-                </c:pt>
-              </c:strCache>
-            </c:strRef>
-          </c:tx>
-          <c:spPr>
-            <a:solidFill>
-              <a:srgbClr val="5C7A73"/>
-            </a:solidFill>
-            <a:effectLst/>
-          </c:spPr>
-          <c:invertIfNegative val="0"/>
-          <c:dLbls>
-            <c:numFmt formatCode="0&quot;%&quot;" sourceLinked="0"/>
-            <c:txPr>
-              <a:bodyPr/>
-              <a:lstStyle/>
-              <a:p>
-                <a:pPr>
-                  <a:defRPr b="0" i="0" strike="noStrike" sz="950" u="none">
-                    <a:solidFill>
-                      <a:srgbClr val="FFFFFF"/>
-                    </a:solidFill>
-                    <a:latin typeface="Arial"/>
-                  </a:defRPr>
-                </a:pPr>
-              </a:p>
-            </c:txPr>
-            <c:dLblPos val="ctr"/>
-            <c:showLegendKey val="0"/>
-            <c:showVal val="1"/>
-            <c:showCatName val="0"/>
-            <c:showSerName val="0"/>
-            <c:showPercent val="0"/>
-            <c:showBubbleSize val="0"/>
-            <c:showLeaderLines val="0"/>
-          </c:dLbls>
-          <c:cat>
-            <c:multiLvlStrRef>
-              <c:f>Sheet1!$A$2:$A$2</c:f>
-              <c:multiLvlStrCache>
-                <c:ptCount val="1"/>
-                <c:lvl>
-                  <c:pt idx="0">
-                    <c:v>Mix</c:v>
-                  </c:pt>
-                </c:lvl>
-              </c:multiLvlStrCache>
-            </c:multiLvlStrRef>
-          </c:cat>
-          <c:val>
-            <c:numRef>
-              <c:f>Sheet1!$E$2:$E$2</c:f>
-              <c:numCache>
-                <c:formatCode>General</c:formatCode>
-                <c:ptCount val="1"/>
-                <c:pt idx="0">
-                  <c:v>10</c:v>
-                </c:pt>
-              </c:numCache>
-            </c:numRef>
-          </c:val>
-        </c:ser>
-        <c:ser>
-          <c:idx val="4"/>
-          <c:order val="4"/>
-          <c:tx>
-            <c:strRef>
-              <c:f>Sheet1!$F$1</c:f>
-              <c:strCache>
-                <c:ptCount val="1"/>
-                <c:pt idx="0">
-                  <c:v>Cash</c:v>
+                  <c:v>Liquidity</c:v>
                 </c:pt>
               </c:strCache>
             </c:strRef>
@@ -1138,12 +1066,12 @@
           </c:cat>
           <c:val>
             <c:numRef>
-              <c:f>Sheet1!$F$2:$F$2</c:f>
+              <c:f>Sheet1!$E$2:$E$2</c:f>
               <c:numCache>
                 <c:formatCode>General</c:formatCode>
                 <c:ptCount val="1"/>
                 <c:pt idx="0">
-                  <c:v>5</c:v>
+                  <c:v>10</c:v>
                 </c:pt>
               </c:numCache>
             </c:numRef>
@@ -4467,7 +4395,7 @@
                           <a:ea typeface="Calibri" pitchFamily="34" charset="-122"/>
                           <a:cs typeface="Calibri" pitchFamily="34" charset="-120"/>
                         </a:rPr>
-                        <a:t>Loan-to-value and rate risk</a:t>
+                        <a:t>LTV/rate risk; running-cost portfolio shortfall</a:t>
                       </a:r>
                       <a:endParaRPr lang="en-US" sz="1150" dirty="0">
                         <a:latin typeface="Calibri" charset="0"/>
@@ -4535,7 +4463,7 @@
                           <a:ea typeface="Calibri" pitchFamily="34" charset="-122"/>
                           <a:cs typeface="Calibri" pitchFamily="34" charset="-120"/>
                         </a:rPr>
-                        <a:t>LTV covenant + rate-hedge review</a:t>
+                        <a:t>LTV &amp; rate-hedge review + portfolio stress test</a:t>
                       </a:r>
                       <a:endParaRPr lang="en-US" sz="1150" dirty="0">
                         <a:latin typeface="Calibri" charset="0"/>
@@ -8085,7 +8013,7 @@
                 <a:ea typeface="Calibri" pitchFamily="34" charset="-122"/>
                 <a:cs typeface="Calibri" pitchFamily="34" charset="-120"/>
               </a:rPr>
-              <a:t>Lending-led structure funding purchase and running costs.</a:t>
+              <a:t>Two lending levers fund the purchase; a dedicated $30m portfolio covers running costs.</a:t>
             </a:r>
             <a:endParaRPr lang="en-US" sz="1100" dirty="0"/>
           </a:p>
@@ -9294,7 +9222,7 @@
                 <a:ea typeface="Calibri" pitchFamily="34" charset="-122"/>
                 <a:cs typeface="Calibri" pitchFamily="34" charset="-120"/>
               </a:rPr>
-              <a:t>The yacht facility is funded through securities-backed lending collateralised against Pools 1–2 and the liquidity reserve — it is a liability structure, not a separate capital allocation.</a:t>
+              <a:t>The yacht purchase is funded through two lending facilities collateralised against Pools 1–2 and the vessel itself. Running costs are covered separately by a dedicated $30m Pool 3 portfolio targeting 6% p.a. — Pool 2 is never drawn on.</a:t>
             </a:r>
             <a:endParaRPr lang="en-US" sz="1050" dirty="0"/>
           </a:p>
@@ -10757,7 +10685,7 @@
                 <a:ea typeface="Calibri" pitchFamily="34" charset="-122"/>
                 <a:cs typeface="Calibri" pitchFamily="34" charset="-120"/>
               </a:rPr>
-              <a:t>The Core Portfolio · Target 7.5% p.a. Total Return</a:t>
+              <a:t>The Core Portfolio · 7.5% p.a. Target — 3% Distributed, 4.5% Growth</a:t>
             </a:r>
             <a:endParaRPr lang="en-US" sz="1350" dirty="0"/>
           </a:p>
@@ -10838,7 +10766,7 @@
                 <a:ea typeface="Calibri" pitchFamily="34" charset="-122"/>
                 <a:cs typeface="Calibri" pitchFamily="34" charset="-120"/>
               </a:rPr>
-              <a:t>A diversified, liquid core portfolio blending income and growth to deliver a consistent 7.5% p.a. total return through market cycles.</a:t>
+              <a:t>A diversified, liquid core portfolio delivering 7.5% p.a., of which 3% is distributed as running yield and 4.5% is retained for capital growth.</a:t>
             </a:r>
             <a:endParaRPr lang="en-US" sz="1300" dirty="0"/>
           </a:p>
@@ -10853,7 +10781,7 @@
         <p:spPr>
           <a:xfrm>
             <a:off x="457200" y="2651760"/>
-            <a:ext cx="5943600" cy="2103120"/>
+            <a:ext cx="5943600" cy="1828800"/>
           </a:xfrm>
           <a:prstGeom prst="rect">
             <a:avLst/>
@@ -10870,7 +10798,7 @@
                 <a:spcPct val="115000"/>
               </a:lnSpc>
               <a:spcAft>
-                <a:spcPts val="600"/>
+                <a:spcPts val="800"/>
               </a:spcAft>
               <a:buSzPct val="100000"/>
               <a:buChar char="●"/>
@@ -10884,7 +10812,7 @@
                 <a:ea typeface="Calibri" pitchFamily="34" charset="-122"/>
                 <a:cs typeface="Calibri" pitchFamily="34" charset="-120"/>
               </a:rPr>
-              <a:t>Global multi-asset mandate spanning equities, credit, real assets and diversifying strategies</a:t>
+              <a:t>Global multi-asset mandate — equities, bonds, alternatives, liquidity</a:t>
             </a:r>
             <a:endParaRPr lang="en-US" sz="1200" dirty="0"/>
           </a:p>
@@ -10894,7 +10822,7 @@
                 <a:spcPct val="115000"/>
               </a:lnSpc>
               <a:spcAft>
-                <a:spcPts val="600"/>
+                <a:spcPts val="800"/>
               </a:spcAft>
               <a:buSzPct val="100000"/>
               <a:buChar char="●"/>
@@ -10908,7 +10836,7 @@
                 <a:ea typeface="Calibri" pitchFamily="34" charset="-122"/>
                 <a:cs typeface="Calibri" pitchFamily="34" charset="-120"/>
               </a:rPr>
-              <a:t>Disciplined rebalancing bands to harvest volatility and control drift</a:t>
+              <a:t>Growth-tilted mix reflects the low distribution rate</a:t>
             </a:r>
             <a:endParaRPr lang="en-US" sz="1200" dirty="0"/>
           </a:p>
@@ -10918,7 +10846,7 @@
                 <a:spcPct val="115000"/>
               </a:lnSpc>
               <a:spcAft>
-                <a:spcPts val="600"/>
+                <a:spcPts val="800"/>
               </a:spcAft>
               <a:buSzPct val="100000"/>
               <a:buChar char="●"/>
@@ -10932,7 +10860,7 @@
                 <a:ea typeface="Calibri" pitchFamily="34" charset="-122"/>
                 <a:cs typeface="Calibri" pitchFamily="34" charset="-120"/>
               </a:rPr>
-              <a:t>Income sleeve engineered to service the Pool 3 lending facility</a:t>
+              <a:t>Natural income of ~3.4% comfortably covers the 3% distribution</a:t>
             </a:r>
             <a:endParaRPr lang="en-US" sz="1200" dirty="0"/>
           </a:p>
@@ -10942,7 +10870,7 @@
                 <a:spcPct val="115000"/>
               </a:lnSpc>
               <a:spcAft>
-                <a:spcPts val="600"/>
+                <a:spcPts val="800"/>
               </a:spcAft>
               <a:buSzPct val="100000"/>
               <a:buChar char="●"/>
@@ -10956,7 +10884,31 @@
                 <a:ea typeface="Calibri" pitchFamily="34" charset="-122"/>
                 <a:cs typeface="Calibri" pitchFamily="34" charset="-120"/>
               </a:rPr>
-              <a:t>Quarterly performance review against the 7.5% p.a. hurdle and peer benchmarks</a:t>
+              <a:t>Disciplined rebalancing bands to harvest volatility and control drift</a:t>
+            </a:r>
+            <a:endParaRPr lang="en-US" sz="1200" dirty="0"/>
+          </a:p>
+          <a:p>
+            <a:pPr marL="177800" indent="-177800">
+              <a:lnSpc>
+                <a:spcPct val="115000"/>
+              </a:lnSpc>
+              <a:spcAft>
+                <a:spcPts val="800"/>
+              </a:spcAft>
+              <a:buSzPct val="100000"/>
+              <a:buChar char="●"/>
+            </a:pPr>
+            <a:r>
+              <a:rPr lang="en-US" sz="1200" dirty="0">
+                <a:solidFill>
+                  <a:srgbClr val="0B1B2B"/>
+                </a:solidFill>
+                <a:latin typeface="Calibri" pitchFamily="34" charset="0"/>
+                <a:ea typeface="Calibri" pitchFamily="34" charset="-122"/>
+                <a:cs typeface="Calibri" pitchFamily="34" charset="-120"/>
+              </a:rPr>
+              <a:t>Performance reviewed quarterly against the 7.5% p.a. hurdle</a:t>
             </a:r>
             <a:endParaRPr lang="en-US" sz="1200" dirty="0"/>
           </a:p>
@@ -11093,8 +11045,8 @@
         </p:nvSpPr>
         <p:spPr>
           <a:xfrm>
-            <a:off x="457200" y="5074920"/>
-            <a:ext cx="4572000" cy="274320"/>
+            <a:off x="457200" y="4572000"/>
+            <a:ext cx="8229600" cy="256032"/>
           </a:xfrm>
           <a:prstGeom prst="rect">
             <a:avLst/>
@@ -11118,7 +11070,7 @@
                 <a:ea typeface="Cambria" pitchFamily="34" charset="-122"/>
                 <a:cs typeface="Cambria" pitchFamily="34" charset="-120"/>
               </a:rPr>
-              <a:t>Illustrative Asset Mix</a:t>
+              <a:t>Illustrative Asset Mix — Solving for 7.5% (3% Yield + 4.5% Growth)</a:t>
             </a:r>
             <a:endParaRPr lang="en-US" sz="1300" dirty="0"/>
           </a:p>
@@ -11131,8 +11083,8 @@
           <p:nvPr/>
         </p:nvGraphicFramePr>
         <p:xfrm>
-          <a:off x="457200" y="5367528"/>
-          <a:ext cx="11247120" cy="1188720"/>
+          <a:off x="457200" y="4864608"/>
+          <a:ext cx="11247120" cy="1051560"/>
         </p:xfrm>
         <a:graphic xmlns:a="http://schemas.openxmlformats.org/drawingml/2006/main">
           <a:graphicData uri="http://schemas.openxmlformats.org/drawingml/2006/chart">
@@ -11148,8 +11100,8 @@
         </p:nvSpPr>
         <p:spPr>
           <a:xfrm>
-            <a:off x="457200" y="6528816"/>
-            <a:ext cx="7315200" cy="256032"/>
+            <a:off x="457200" y="5989320"/>
+            <a:ext cx="11247120" cy="274320"/>
           </a:xfrm>
           <a:prstGeom prst="rect">
             <a:avLst/>
@@ -11165,7 +11117,7 @@
               <a:buNone/>
             </a:pPr>
             <a:r>
-              <a:rPr lang="en-US" sz="850" dirty="0">
+              <a:rPr lang="en-US" sz="900" i="1" dirty="0">
                 <a:solidFill>
                   <a:srgbClr val="8C93A0"/>
                 </a:solidFill>
@@ -11173,6 +11125,45 @@
                 <a:ea typeface="Calibri" pitchFamily="34" charset="-122"/>
                 <a:cs typeface="Calibri" pitchFamily="34" charset="-120"/>
               </a:rPr>
+              <a:t>Illustrative long-run assumptions: Equities 9.0% total return (2.5% yield); Bonds &amp; Credit 5.0% (4.5% yield); Alternatives 8.0% (4.0% yield); Liquidity 4.0%.</a:t>
+            </a:r>
+            <a:endParaRPr lang="en-US" sz="900" dirty="0"/>
+          </a:p>
+        </p:txBody>
+      </p:sp>
+      <p:sp>
+        <p:nvSpPr>
+          <p:cNvPr id="17" name="Text 12"/>
+          <p:cNvSpPr txBox="1"/>
+          <p:nvPr/>
+        </p:nvSpPr>
+        <p:spPr>
+          <a:xfrm>
+            <a:off x="457200" y="6528816"/>
+            <a:ext cx="7315200" cy="256032"/>
+          </a:xfrm>
+          <a:prstGeom prst="rect">
+            <a:avLst/>
+          </a:prstGeom>
+          <a:noFill/>
+          <a:ln/>
+        </p:spPr>
+        <p:txBody>
+          <a:bodyPr wrap="square" rtlCol="0" anchor="ctr"/>
+          <a:lstStyle/>
+          <a:p>
+            <a:pPr indent="0" marL="0">
+              <a:buNone/>
+            </a:pPr>
+            <a:r>
+              <a:rPr lang="en-US" sz="850" dirty="0">
+                <a:solidFill>
+                  <a:srgbClr val="8C93A0"/>
+                </a:solidFill>
+                <a:latin typeface="Calibri" pitchFamily="34" charset="0"/>
+                <a:ea typeface="Calibri" pitchFamily="34" charset="-122"/>
+                <a:cs typeface="Calibri" pitchFamily="34" charset="-120"/>
+              </a:rPr>
               <a:t>Private Wealth Advisory · Strictly Private &amp; Confidential</a:t>
             </a:r>
             <a:endParaRPr lang="en-US" sz="850" dirty="0"/>
@@ -11181,7 +11172,7 @@
       </p:sp>
       <p:sp>
         <p:nvSpPr>
-          <p:cNvPr id="17" name="Text 12"/>
+          <p:cNvPr id="18" name="Text 13"/>
           <p:cNvSpPr txBox="1"/>
           <p:nvPr/>
         </p:nvSpPr>
@@ -11486,7 +11477,7 @@
                 <a:ea typeface="Calibri" pitchFamily="34" charset="-122"/>
                 <a:cs typeface="Calibri" pitchFamily="34" charset="-120"/>
               </a:rPr>
-              <a:t>Fund the yacht purchase and its ongoing running costs by blending two lending levers, preserving Pools 1 and 2 to keep compounding uninterrupted.</a:t>
+              <a:t>Fund the purchase through two blendable lending levers, and cover running costs from a dedicated $30m portfolio — without ever drawing on Pool 2.</a:t>
             </a:r>
             <a:endParaRPr lang="en-US" sz="1300" dirty="0"/>
           </a:p>
@@ -11501,7 +11492,7 @@
         <p:spPr>
           <a:xfrm>
             <a:off x="457200" y="2788920"/>
-            <a:ext cx="6035040" cy="3291840"/>
+            <a:ext cx="6035040" cy="3383280"/>
           </a:xfrm>
           <a:prstGeom prst="rect">
             <a:avLst/>
@@ -11518,13 +11509,13 @@
                 <a:spcPct val="115000"/>
               </a:lnSpc>
               <a:spcAft>
-                <a:spcPts val="900"/>
+                <a:spcPts val="800"/>
               </a:spcAft>
               <a:buSzPct val="100000"/>
               <a:buChar char="●"/>
             </a:pPr>
             <a:r>
-              <a:rPr lang="en-US" sz="1250" dirty="0">
+              <a:rPr lang="en-US" sz="1200" dirty="0">
                 <a:solidFill>
                   <a:srgbClr val="0B1B2B"/>
                 </a:solidFill>
@@ -11532,9 +11523,9 @@
                 <a:ea typeface="Calibri" pitchFamily="34" charset="-122"/>
                 <a:cs typeface="Calibri" pitchFamily="34" charset="-120"/>
               </a:rPr>
-              <a:t>Fund the purchase by blending two lending levers rather than drawing on a single source</a:t>
-            </a:r>
-            <a:endParaRPr lang="en-US" sz="1250" dirty="0"/>
+              <a:t>Portfolio margin (Lombard) facility collateralised against Pools 1–2 and the liquidity reserve, typically ~30% LTV</a:t>
+            </a:r>
+            <a:endParaRPr lang="en-US" sz="1200" dirty="0"/>
           </a:p>
           <a:p>
             <a:pPr marL="177800" indent="-177800">
@@ -11542,13 +11533,13 @@
                 <a:spcPct val="115000"/>
               </a:lnSpc>
               <a:spcAft>
-                <a:spcPts val="900"/>
+                <a:spcPts val="800"/>
               </a:spcAft>
               <a:buSzPct val="100000"/>
               <a:buChar char="●"/>
             </a:pPr>
             <a:r>
-              <a:rPr lang="en-US" sz="1250" dirty="0">
+              <a:rPr lang="en-US" sz="1200" dirty="0">
                 <a:solidFill>
                   <a:srgbClr val="0B1B2B"/>
                 </a:solidFill>
@@ -11556,9 +11547,9 @@
                 <a:ea typeface="Calibri" pitchFamily="34" charset="-122"/>
                 <a:cs typeface="Calibri" pitchFamily="34" charset="-120"/>
               </a:rPr>
-              <a:t>Portfolio margin (Lombard) facility collateralised against Pools 1–2 and the liquidity reserve, typically ~30% LTV</a:t>
-            </a:r>
-            <a:endParaRPr lang="en-US" sz="1250" dirty="0"/>
+              <a:t>Marine mortgage collateralised directly against the vessel itself, available up to ~50% LTV — freeing up portfolio margin headroom</a:t>
+            </a:r>
+            <a:endParaRPr lang="en-US" sz="1200" dirty="0"/>
           </a:p>
           <a:p>
             <a:pPr marL="177800" indent="-177800">
@@ -11566,13 +11557,13 @@
                 <a:spcPct val="115000"/>
               </a:lnSpc>
               <a:spcAft>
-                <a:spcPts val="900"/>
+                <a:spcPts val="800"/>
               </a:spcAft>
               <a:buSzPct val="100000"/>
               <a:buChar char="●"/>
             </a:pPr>
             <a:r>
-              <a:rPr lang="en-US" sz="1250" dirty="0">
+              <a:rPr lang="en-US" sz="1200" dirty="0">
                 <a:solidFill>
                   <a:srgbClr val="0B1B2B"/>
                 </a:solidFill>
@@ -11580,9 +11571,9 @@
                 <a:ea typeface="Calibri" pitchFamily="34" charset="-122"/>
                 <a:cs typeface="Calibri" pitchFamily="34" charset="-120"/>
               </a:rPr>
-              <a:t>Marine mortgage collateralised directly against the vessel itself, available up to ~50% LTV — freeing up portfolio margin headroom</a:t>
-            </a:r>
-            <a:endParaRPr lang="en-US" sz="1250" dirty="0"/>
+              <a:t>Running costs are funded independently by a dedicated $30m Pool 3 portfolio targeting 6% p.a. — not by Pool 2 income</a:t>
+            </a:r>
+            <a:endParaRPr lang="en-US" sz="1200" dirty="0"/>
           </a:p>
           <a:p>
             <a:pPr marL="177800" indent="-177800">
@@ -11590,13 +11581,13 @@
                 <a:spcPct val="115000"/>
               </a:lnSpc>
               <a:spcAft>
-                <a:spcPts val="900"/>
+                <a:spcPts val="800"/>
               </a:spcAft>
               <a:buSzPct val="100000"/>
               <a:buChar char="●"/>
             </a:pPr>
             <a:r>
-              <a:rPr lang="en-US" sz="1250" dirty="0">
+              <a:rPr lang="en-US" sz="1200" dirty="0">
                 <a:solidFill>
                   <a:srgbClr val="0B1B2B"/>
                 </a:solidFill>
@@ -11604,9 +11595,9 @@
                 <a:ea typeface="Calibri" pitchFamily="34" charset="-122"/>
                 <a:cs typeface="Calibri" pitchFamily="34" charset="-120"/>
               </a:rPr>
-              <a:t>Running costs (crew, maintenance, insurance, berthing), roughly 10% of vessel value p.a., drawn as a revolving line, never funded from core capital</a:t>
-            </a:r>
-            <a:endParaRPr lang="en-US" sz="1250" dirty="0"/>
+              <a:t>At 6% p.a. the dedicated portfolio generates ~$1.8m annually, covering crew, maintenance, insurance and berthing (assumed ~10% of vessel value p.a.)</a:t>
+            </a:r>
+            <a:endParaRPr lang="en-US" sz="1200" dirty="0"/>
           </a:p>
           <a:p>
             <a:pPr marL="177800" indent="-177800">
@@ -11614,13 +11605,13 @@
                 <a:spcPct val="115000"/>
               </a:lnSpc>
               <a:spcAft>
-                <a:spcPts val="900"/>
+                <a:spcPts val="800"/>
               </a:spcAft>
               <a:buSzPct val="100000"/>
               <a:buChar char="●"/>
             </a:pPr>
             <a:r>
-              <a:rPr lang="en-US" sz="1250" dirty="0">
+              <a:rPr lang="en-US" sz="1200" dirty="0">
                 <a:solidFill>
                   <a:srgbClr val="0B1B2B"/>
                 </a:solidFill>
@@ -11628,9 +11619,9 @@
                 <a:ea typeface="Calibri" pitchFamily="34" charset="-122"/>
                 <a:cs typeface="Calibri" pitchFamily="34" charset="-120"/>
               </a:rPr>
-              <a:t>Blend, rate hedge and covenant headroom across both facilities reviewed at each Investment Committee meeting</a:t>
-            </a:r>
-            <a:endParaRPr lang="en-US" sz="1250" dirty="0"/>
+              <a:t>Financing blend, rate hedge and running-cost portfolio performance reviewed together at each Investment Committee meeting</a:t>
+            </a:r>
+            <a:endParaRPr lang="en-US" sz="1200" dirty="0"/>
           </a:p>
         </p:txBody>
       </p:sp>
@@ -11643,11 +11634,11 @@
         <p:spPr>
           <a:xfrm>
             <a:off x="6903720" y="1783080"/>
-            <a:ext cx="2331720" cy="1234440"/>
+            <a:ext cx="2331720" cy="1051560"/>
           </a:xfrm>
           <a:prstGeom prst="roundRect">
             <a:avLst>
-              <a:gd name="adj" fmla="val 5926"/>
+              <a:gd name="adj" fmla="val 6957"/>
             </a:avLst>
           </a:prstGeom>
           <a:solidFill>
@@ -11672,7 +11663,7 @@
         <p:spPr>
           <a:xfrm>
             <a:off x="7068312" y="1892808"/>
-            <a:ext cx="2002536" cy="667512"/>
+            <a:ext cx="2002536" cy="484632"/>
           </a:xfrm>
           <a:prstGeom prst="rect">
             <a:avLst/>
@@ -11710,7 +11701,7 @@
         </p:nvSpPr>
         <p:spPr>
           <a:xfrm>
-            <a:off x="7068312" y="2596896"/>
+            <a:off x="7068312" y="2414016"/>
             <a:ext cx="2002536" cy="365760"/>
           </a:xfrm>
           <a:prstGeom prst="rect">
@@ -11750,11 +11741,11 @@
         <p:spPr>
           <a:xfrm>
             <a:off x="9372600" y="1783080"/>
-            <a:ext cx="2331720" cy="1234440"/>
+            <a:ext cx="2331720" cy="1051560"/>
           </a:xfrm>
           <a:prstGeom prst="roundRect">
             <a:avLst>
-              <a:gd name="adj" fmla="val 5926"/>
+              <a:gd name="adj" fmla="val 6957"/>
             </a:avLst>
           </a:prstGeom>
           <a:solidFill>
@@ -11779,7 +11770,7 @@
         <p:spPr>
           <a:xfrm>
             <a:off x="9537192" y="1892808"/>
-            <a:ext cx="2002536" cy="667512"/>
+            <a:ext cx="2002536" cy="484632"/>
           </a:xfrm>
           <a:prstGeom prst="rect">
             <a:avLst/>
@@ -11817,7 +11808,7 @@
         </p:nvSpPr>
         <p:spPr>
           <a:xfrm>
-            <a:off x="9537192" y="2596896"/>
+            <a:off x="9537192" y="2414016"/>
             <a:ext cx="2002536" cy="365760"/>
           </a:xfrm>
           <a:prstGeom prst="rect">
@@ -11856,12 +11847,12 @@
         </p:nvSpPr>
         <p:spPr>
           <a:xfrm>
-            <a:off x="6903720" y="3108960"/>
-            <a:ext cx="4800600" cy="3291840"/>
+            <a:off x="6903720" y="2971800"/>
+            <a:ext cx="4800600" cy="1371600"/>
           </a:xfrm>
           <a:prstGeom prst="roundRect">
             <a:avLst>
-              <a:gd name="adj" fmla="val 2222"/>
+              <a:gd name="adj" fmla="val 5333"/>
             </a:avLst>
           </a:prstGeom>
           <a:solidFill>
@@ -11890,8 +11881,8 @@
         </p:nvSpPr>
         <p:spPr>
           <a:xfrm>
-            <a:off x="7159752" y="3273552"/>
-            <a:ext cx="4288536" cy="274320"/>
+            <a:off x="7159752" y="3118104"/>
+            <a:ext cx="4288536" cy="256032"/>
           </a:xfrm>
           <a:prstGeom prst="rect">
             <a:avLst/>
@@ -11907,7 +11898,7 @@
               <a:buNone/>
             </a:pPr>
             <a:r>
-              <a:rPr lang="en-US" sz="1250" b="1" dirty="0">
+              <a:rPr lang="en-US" sz="1200" b="1" dirty="0">
                 <a:solidFill>
                   <a:srgbClr val="0B1B2B"/>
                 </a:solidFill>
@@ -11915,9 +11906,9 @@
                 <a:ea typeface="Cambria" pitchFamily="34" charset="-122"/>
                 <a:cs typeface="Cambria" pitchFamily="34" charset="-120"/>
               </a:rPr>
-              <a:t>Two lending levers, blended</a:t>
-            </a:r>
-            <a:endParaRPr lang="en-US" sz="1250" dirty="0"/>
+              <a:t>Acquisition Financing — Two Levers</a:t>
+            </a:r>
+            <a:endParaRPr lang="en-US" sz="1200" dirty="0"/>
           </a:p>
         </p:txBody>
       </p:sp>
@@ -11929,8 +11920,8 @@
         </p:nvSpPr>
         <p:spPr>
           <a:xfrm>
-            <a:off x="7159752" y="3648456"/>
-            <a:ext cx="146304" cy="146304"/>
+            <a:off x="7159752" y="3511296"/>
+            <a:ext cx="128016" cy="128016"/>
           </a:xfrm>
           <a:prstGeom prst="ellipse">
             <a:avLst/>
@@ -11949,17 +11940,17 @@
         </p:nvSpPr>
         <p:spPr>
           <a:xfrm>
-            <a:off x="7434072" y="3547872"/>
-            <a:ext cx="3246120" cy="457200"/>
-          </a:xfrm>
-          <a:prstGeom prst="rect">
-            <a:avLst/>
-          </a:prstGeom>
-          <a:noFill/>
-          <a:ln/>
-        </p:spPr>
-        <p:txBody>
-          <a:bodyPr wrap="square" lIns="0" tIns="0" rIns="0" bIns="0" rtlCol="0" anchor="ctr"/>
+            <a:off x="7397496" y="3410712"/>
+            <a:ext cx="3246120" cy="310896"/>
+          </a:xfrm>
+          <a:prstGeom prst="rect">
+            <a:avLst/>
+          </a:prstGeom>
+          <a:noFill/>
+          <a:ln/>
+        </p:spPr>
+        <p:txBody>
+          <a:bodyPr wrap="square" lIns="0" tIns="0" rIns="0" bIns="0" rtlCol="0" anchor="t"/>
           <a:lstStyle/>
           <a:p>
             <a:pPr indent="0" marL="0">
@@ -11969,7 +11960,7 @@
               <a:buNone/>
             </a:pPr>
             <a:r>
-              <a:rPr lang="en-US" sz="1150" b="1" dirty="0">
+              <a:rPr lang="en-US" sz="1050" b="1" dirty="0">
                 <a:solidFill>
                   <a:srgbClr val="0B1B2B"/>
                 </a:solidFill>
@@ -11979,7 +11970,7 @@
               </a:rPr>
               <a:t>Portfolio Margin Loan</a:t>
             </a:r>
-            <a:endParaRPr lang="en-US" sz="1150" dirty="0"/>
+            <a:endParaRPr lang="en-US" sz="1050" dirty="0"/>
           </a:p>
         </p:txBody>
       </p:sp>
@@ -11991,8 +11982,8 @@
         </p:nvSpPr>
         <p:spPr>
           <a:xfrm>
-            <a:off x="10469880" y="3547872"/>
-            <a:ext cx="1005840" cy="274320"/>
+            <a:off x="10515600" y="3392424"/>
+            <a:ext cx="960120" cy="274320"/>
           </a:xfrm>
           <a:prstGeom prst="roundRect">
             <a:avLst>
@@ -12013,8 +12004,8 @@
         </p:nvSpPr>
         <p:spPr>
           <a:xfrm>
-            <a:off x="10469880" y="3547872"/>
-            <a:ext cx="1005840" cy="274320"/>
+            <a:off x="10515600" y="3392424"/>
+            <a:ext cx="960120" cy="274320"/>
           </a:xfrm>
           <a:prstGeom prst="rect">
             <a:avLst/>
@@ -12046,56 +12037,14 @@
       </p:sp>
       <p:sp>
         <p:nvSpPr>
-          <p:cNvPr id="22" name="Text 19"/>
-          <p:cNvSpPr txBox="1"/>
-          <p:nvPr/>
-        </p:nvSpPr>
-        <p:spPr>
-          <a:xfrm>
-            <a:off x="7434072" y="3840480"/>
-            <a:ext cx="4014216" cy="457200"/>
-          </a:xfrm>
-          <a:prstGeom prst="rect">
-            <a:avLst/>
-          </a:prstGeom>
-          <a:noFill/>
-          <a:ln/>
-        </p:spPr>
-        <p:txBody>
-          <a:bodyPr wrap="square" rtlCol="0" anchor="ctr"/>
-          <a:lstStyle/>
-          <a:p>
-            <a:pPr indent="0" marL="0">
-              <a:lnSpc>
-                <a:spcPct val="112000"/>
-              </a:lnSpc>
-              <a:buNone/>
-            </a:pPr>
-            <a:r>
-              <a:rPr lang="en-US" sz="1000" dirty="0">
-                <a:solidFill>
-                  <a:srgbClr val="8C93A0"/>
-                </a:solidFill>
-                <a:latin typeface="Calibri" pitchFamily="34" charset="0"/>
-                <a:ea typeface="Calibri" pitchFamily="34" charset="-122"/>
-                <a:cs typeface="Calibri" pitchFamily="34" charset="-120"/>
-              </a:rPr>
-              <a:t>Collateralised against Pools 1–2; lower cost, broad flexibility</a:t>
-            </a:r>
-            <a:endParaRPr lang="en-US" sz="1000" dirty="0"/>
-          </a:p>
-        </p:txBody>
-      </p:sp>
-      <p:sp>
-        <p:nvSpPr>
-          <p:cNvPr id="23" name="Shape 20"/>
+          <p:cNvPr id="22" name="Shape 19"/>
           <p:cNvSpPr/>
           <p:nvPr/>
         </p:nvSpPr>
         <p:spPr>
           <a:xfrm>
-            <a:off x="7159752" y="4425696"/>
-            <a:ext cx="146304" cy="146304"/>
+            <a:off x="7159752" y="3895344"/>
+            <a:ext cx="128016" cy="128016"/>
           </a:xfrm>
           <a:prstGeom prst="ellipse">
             <a:avLst/>
@@ -12108,23 +12057,23 @@
       </p:sp>
       <p:sp>
         <p:nvSpPr>
-          <p:cNvPr id="24" name="Text 21"/>
-          <p:cNvSpPr txBox="1"/>
-          <p:nvPr/>
-        </p:nvSpPr>
-        <p:spPr>
-          <a:xfrm>
-            <a:off x="7434072" y="4325112"/>
-            <a:ext cx="3246120" cy="457200"/>
-          </a:xfrm>
-          <a:prstGeom prst="rect">
-            <a:avLst/>
-          </a:prstGeom>
-          <a:noFill/>
-          <a:ln/>
-        </p:spPr>
-        <p:txBody>
-          <a:bodyPr wrap="square" lIns="0" tIns="0" rIns="0" bIns="0" rtlCol="0" anchor="ctr"/>
+          <p:cNvPr id="23" name="Text 20"/>
+          <p:cNvSpPr txBox="1"/>
+          <p:nvPr/>
+        </p:nvSpPr>
+        <p:spPr>
+          <a:xfrm>
+            <a:off x="7397496" y="3794760"/>
+            <a:ext cx="3246120" cy="310896"/>
+          </a:xfrm>
+          <a:prstGeom prst="rect">
+            <a:avLst/>
+          </a:prstGeom>
+          <a:noFill/>
+          <a:ln/>
+        </p:spPr>
+        <p:txBody>
+          <a:bodyPr wrap="square" lIns="0" tIns="0" rIns="0" bIns="0" rtlCol="0" anchor="t"/>
           <a:lstStyle/>
           <a:p>
             <a:pPr indent="0" marL="0">
@@ -12134,7 +12083,7 @@
               <a:buNone/>
             </a:pPr>
             <a:r>
-              <a:rPr lang="en-US" sz="1150" b="1" dirty="0">
+              <a:rPr lang="en-US" sz="1050" b="1" dirty="0">
                 <a:solidFill>
                   <a:srgbClr val="0B1B2B"/>
                 </a:solidFill>
@@ -12142,42 +12091,22 @@
                 <a:ea typeface="Calibri" pitchFamily="34" charset="-122"/>
                 <a:cs typeface="Calibri" pitchFamily="34" charset="-120"/>
               </a:rPr>
-              <a:t>Yacht-Secured Loan</a:t>
-            </a:r>
-            <a:endParaRPr lang="en-US" sz="1150" dirty="0"/>
-          </a:p>
-          <a:p>
-            <a:pPr indent="0" marL="0">
-              <a:lnSpc>
-                <a:spcPct val="105000"/>
-              </a:lnSpc>
-              <a:buNone/>
-            </a:pPr>
-            <a:r>
-              <a:rPr lang="en-US" sz="1150" b="1" dirty="0">
-                <a:solidFill>
-                  <a:srgbClr val="0B1B2B"/>
-                </a:solidFill>
-                <a:latin typeface="Calibri" pitchFamily="34" charset="0"/>
-                <a:ea typeface="Calibri" pitchFamily="34" charset="-122"/>
-                <a:cs typeface="Calibri" pitchFamily="34" charset="-120"/>
-              </a:rPr>
-              <a:t>(Marine Mortgage)</a:t>
-            </a:r>
-            <a:endParaRPr lang="en-US" sz="1150" dirty="0"/>
-          </a:p>
-        </p:txBody>
-      </p:sp>
-      <p:sp>
-        <p:nvSpPr>
-          <p:cNvPr id="25" name="Shape 22"/>
+              <a:t>Yacht-Secured Loan (Marine Mortgage)</a:t>
+            </a:r>
+            <a:endParaRPr lang="en-US" sz="1050" dirty="0"/>
+          </a:p>
+        </p:txBody>
+      </p:sp>
+      <p:sp>
+        <p:nvSpPr>
+          <p:cNvPr id="24" name="Shape 21"/>
           <p:cNvSpPr/>
           <p:nvPr/>
         </p:nvSpPr>
         <p:spPr>
           <a:xfrm>
-            <a:off x="10469880" y="4325112"/>
-            <a:ext cx="1005840" cy="274320"/>
+            <a:off x="10515600" y="3776472"/>
+            <a:ext cx="960120" cy="274320"/>
           </a:xfrm>
           <a:prstGeom prst="roundRect">
             <a:avLst>
@@ -12192,14 +12121,14 @@
       </p:sp>
       <p:sp>
         <p:nvSpPr>
-          <p:cNvPr id="26" name="Text 23"/>
-          <p:cNvSpPr txBox="1"/>
-          <p:nvPr/>
-        </p:nvSpPr>
-        <p:spPr>
-          <a:xfrm>
-            <a:off x="10469880" y="4325112"/>
-            <a:ext cx="1005840" cy="274320"/>
+          <p:cNvPr id="25" name="Text 22"/>
+          <p:cNvSpPr txBox="1"/>
+          <p:nvPr/>
+        </p:nvSpPr>
+        <p:spPr>
+          <a:xfrm>
+            <a:off x="10515600" y="3776472"/>
+            <a:ext cx="960120" cy="274320"/>
           </a:xfrm>
           <a:prstGeom prst="rect">
             <a:avLst/>
@@ -12231,14 +12160,43 @@
       </p:sp>
       <p:sp>
         <p:nvSpPr>
+          <p:cNvPr id="26" name="Shape 23"/>
+          <p:cNvSpPr/>
+          <p:nvPr/>
+        </p:nvSpPr>
+        <p:spPr>
+          <a:xfrm>
+            <a:off x="6903720" y="4480560"/>
+            <a:ext cx="4800600" cy="1828800"/>
+          </a:xfrm>
+          <a:prstGeom prst="roundRect">
+            <a:avLst>
+              <a:gd name="adj" fmla="val 4000"/>
+            </a:avLst>
+          </a:prstGeom>
+          <a:solidFill>
+            <a:srgbClr val="0B1B2B"/>
+          </a:solidFill>
+          <a:ln/>
+          <a:effectLst>
+            <a:outerShdw sx="100000" sy="100000" kx="0" ky="0" algn="bl" rotWithShape="0" blurRad="101600" dist="38100" dir="5400000">
+              <a:srgbClr val="071320">
+                <a:alpha val="25000"/>
+              </a:srgbClr>
+            </a:outerShdw>
+          </a:effectLst>
+        </p:spPr>
+      </p:sp>
+      <p:sp>
+        <p:nvSpPr>
           <p:cNvPr id="27" name="Text 24"/>
           <p:cNvSpPr txBox="1"/>
           <p:nvPr/>
         </p:nvSpPr>
         <p:spPr>
           <a:xfrm>
-            <a:off x="7434072" y="4800600"/>
-            <a:ext cx="4014216" cy="457200"/>
+            <a:off x="7159752" y="4645152"/>
+            <a:ext cx="4288536" cy="256032"/>
           </a:xfrm>
           <a:prstGeom prst="rect">
             <a:avLst/>
@@ -12251,68 +12209,120 @@
           <a:lstStyle/>
           <a:p>
             <a:pPr indent="0" marL="0">
-              <a:lnSpc>
-                <a:spcPct val="112000"/>
-              </a:lnSpc>
-              <a:buNone/>
-            </a:pPr>
-            <a:r>
-              <a:rPr lang="en-US" sz="1000" dirty="0">
-                <a:solidFill>
-                  <a:srgbClr val="8C93A0"/>
+              <a:buNone/>
+            </a:pPr>
+            <a:r>
+              <a:rPr lang="en-US" sz="1200" b="1" dirty="0">
+                <a:solidFill>
+                  <a:srgbClr val="FFFFFF"/>
+                </a:solidFill>
+                <a:latin typeface="Cambria" pitchFamily="34" charset="0"/>
+                <a:ea typeface="Cambria" pitchFamily="34" charset="-122"/>
+                <a:cs typeface="Cambria" pitchFamily="34" charset="-120"/>
+              </a:rPr>
+              <a:t>Running-Cost Portfolio — Pool 3</a:t>
+            </a:r>
+            <a:endParaRPr lang="en-US" sz="1200" dirty="0"/>
+          </a:p>
+        </p:txBody>
+      </p:sp>
+      <p:sp>
+        <p:nvSpPr>
+          <p:cNvPr id="28" name="Text 25"/>
+          <p:cNvSpPr txBox="1"/>
+          <p:nvPr/>
+        </p:nvSpPr>
+        <p:spPr>
+          <a:xfrm>
+            <a:off x="7159752" y="4937760"/>
+            <a:ext cx="4288536" cy="502920"/>
+          </a:xfrm>
+          <a:prstGeom prst="rect">
+            <a:avLst/>
+          </a:prstGeom>
+          <a:noFill/>
+          <a:ln/>
+        </p:spPr>
+        <p:txBody>
+          <a:bodyPr wrap="square" lIns="0" tIns="0" rIns="0" bIns="0" rtlCol="0" anchor="ctr"/>
+          <a:lstStyle/>
+          <a:p>
+            <a:pPr indent="0" marL="0">
+              <a:buNone/>
+            </a:pPr>
+            <a:r>
+              <a:rPr lang="en-US" sz="2600" b="1" dirty="0">
+                <a:solidFill>
+                  <a:srgbClr val="C6A15B"/>
+                </a:solidFill>
+                <a:latin typeface="Cambria" pitchFamily="34" charset="0"/>
+                <a:ea typeface="Cambria" pitchFamily="34" charset="-122"/>
+                <a:cs typeface="Cambria" pitchFamily="34" charset="-120"/>
+              </a:rPr>
+              <a:t>$30m at 6% p.a.</a:t>
+            </a:r>
+            <a:endParaRPr lang="en-US" sz="2600" dirty="0"/>
+          </a:p>
+        </p:txBody>
+      </p:sp>
+      <p:sp>
+        <p:nvSpPr>
+          <p:cNvPr id="29" name="Text 26"/>
+          <p:cNvSpPr txBox="1"/>
+          <p:nvPr/>
+        </p:nvSpPr>
+        <p:spPr>
+          <a:xfrm>
+            <a:off x="7159752" y="5468112"/>
+            <a:ext cx="4288536" cy="274320"/>
+          </a:xfrm>
+          <a:prstGeom prst="rect">
+            <a:avLst/>
+          </a:prstGeom>
+          <a:noFill/>
+          <a:ln/>
+        </p:spPr>
+        <p:txBody>
+          <a:bodyPr wrap="square" rtlCol="0" anchor="ctr"/>
+          <a:lstStyle/>
+          <a:p>
+            <a:pPr indent="0" marL="0">
+              <a:buNone/>
+            </a:pPr>
+            <a:r>
+              <a:rPr lang="en-US" sz="1050" dirty="0">
+                <a:solidFill>
+                  <a:srgbClr val="F6F3EC"/>
                 </a:solidFill>
                 <a:latin typeface="Calibri" pitchFamily="34" charset="0"/>
                 <a:ea typeface="Calibri" pitchFamily="34" charset="-122"/>
                 <a:cs typeface="Calibri" pitchFamily="34" charset="-120"/>
               </a:rPr>
-              <a:t>Collateralised against the vessel itself; frees portfolio margin headroom</a:t>
-            </a:r>
-            <a:endParaRPr lang="en-US" sz="1000" dirty="0"/>
-          </a:p>
-        </p:txBody>
-      </p:sp>
-      <p:sp>
-        <p:nvSpPr>
-          <p:cNvPr id="28" name="Shape 25"/>
-          <p:cNvSpPr/>
-          <p:nvPr/>
-        </p:nvSpPr>
-        <p:spPr>
-          <a:xfrm>
-            <a:off x="7159752" y="5285232"/>
-            <a:ext cx="4288536" cy="0"/>
-          </a:xfrm>
-          <a:prstGeom prst="line">
-            <a:avLst/>
-          </a:prstGeom>
-          <a:noFill/>
-          <a:ln w="12700">
-            <a:solidFill>
-              <a:srgbClr val="E3DFD3"/>
-            </a:solidFill>
-            <a:prstDash val="solid"/>
-          </a:ln>
-        </p:spPr>
-      </p:sp>
-      <p:sp>
-        <p:nvSpPr>
-          <p:cNvPr id="29" name="Text 26"/>
-          <p:cNvSpPr txBox="1"/>
-          <p:nvPr/>
-        </p:nvSpPr>
-        <p:spPr>
-          <a:xfrm>
-            <a:off x="7159752" y="5413248"/>
-            <a:ext cx="4288536" cy="777240"/>
-          </a:xfrm>
-          <a:prstGeom prst="rect">
-            <a:avLst/>
-          </a:prstGeom>
-          <a:noFill/>
-          <a:ln/>
-        </p:spPr>
-        <p:txBody>
-          <a:bodyPr wrap="square" lIns="0" tIns="0" rIns="0" bIns="0" rtlCol="0" anchor="ctr"/>
+              <a:t>Ring-fenced from Pools 1–2 and the acquisition financing</a:t>
+            </a:r>
+            <a:endParaRPr lang="en-US" sz="1050" dirty="0"/>
+          </a:p>
+        </p:txBody>
+      </p:sp>
+      <p:sp>
+        <p:nvSpPr>
+          <p:cNvPr id="30" name="Text 27"/>
+          <p:cNvSpPr txBox="1"/>
+          <p:nvPr/>
+        </p:nvSpPr>
+        <p:spPr>
+          <a:xfrm>
+            <a:off x="7159752" y="5760720"/>
+            <a:ext cx="4288536" cy="502920"/>
+          </a:xfrm>
+          <a:prstGeom prst="rect">
+            <a:avLst/>
+          </a:prstGeom>
+          <a:noFill/>
+          <a:ln/>
+        </p:spPr>
+        <p:txBody>
+          <a:bodyPr wrap="square" rtlCol="0" anchor="ctr"/>
           <a:lstStyle/>
           <a:p>
             <a:pPr indent="0" marL="0">
@@ -12324,13 +12334,13 @@
             <a:r>
               <a:rPr lang="en-US" sz="950" i="1" dirty="0">
                 <a:solidFill>
-                  <a:srgbClr val="8C93A0"/>
+                  <a:srgbClr val="B9C2CC"/>
                 </a:solidFill>
                 <a:latin typeface="Calibri" pitchFamily="34" charset="0"/>
                 <a:ea typeface="Calibri" pitchFamily="34" charset="-122"/>
                 <a:cs typeface="Calibri" pitchFamily="34" charset="-120"/>
               </a:rPr>
-              <a:t>Both facilities can be drawn together — the marine mortgage funds the bulk of the purchase at the higher LTV, with the portfolio margin line as a flexible top-up. Interest and running costs are serviced from Pool 2 income; core capital is never drawn down.</a:t>
+              <a:t>Its own return — not portfolio income — funds crew, maintenance, insurance and berthing, fully independent of the acquisition financing.</a:t>
             </a:r>
             <a:endParaRPr lang="en-US" sz="950" dirty="0"/>
           </a:p>
@@ -12338,7 +12348,7 @@
       </p:sp>
       <p:sp>
         <p:nvSpPr>
-          <p:cNvPr id="30" name="Text 27"/>
+          <p:cNvPr id="31" name="Text 28"/>
           <p:cNvSpPr txBox="1"/>
           <p:nvPr/>
         </p:nvSpPr>
@@ -12377,7 +12387,7 @@
       </p:sp>
       <p:sp>
         <p:nvSpPr>
-          <p:cNvPr id="31" name="Text 28"/>
+          <p:cNvPr id="32" name="Text 29"/>
           <p:cNvSpPr txBox="1"/>
           <p:nvPr/>
         </p:nvSpPr>

</xml_diff>

<commit_message>
Add per-asset-class return assumptions table to Pool 2 slide
Replaces the dense one-line footnote with a proper table showing
weight, yield and total return for each asset class (equities,
bonds & credit, alternatives, liquidity), in the same order as the
asset-mix bar above it, so the 7.5% solve is fully transparent.
</commit_message>
<xml_diff>
--- a/Family_Office_Investment_Strategy.pptx
+++ b/Family_Office_Investment_Strategy.pptx
@@ -817,7 +817,7 @@
               <a:lstStyle/>
               <a:p>
                 <a:pPr>
-                  <a:defRPr b="0" i="0" strike="noStrike" sz="950" u="none">
+                  <a:defRPr b="0" i="0" strike="noStrike" sz="850" u="none">
                     <a:solidFill>
                       <a:srgbClr val="FFFFFF"/>
                     </a:solidFill>
@@ -889,7 +889,7 @@
               <a:lstStyle/>
               <a:p>
                 <a:pPr>
-                  <a:defRPr b="0" i="0" strike="noStrike" sz="950" u="none">
+                  <a:defRPr b="0" i="0" strike="noStrike" sz="850" u="none">
                     <a:solidFill>
                       <a:srgbClr val="FFFFFF"/>
                     </a:solidFill>
@@ -961,7 +961,7 @@
               <a:lstStyle/>
               <a:p>
                 <a:pPr>
-                  <a:defRPr b="0" i="0" strike="noStrike" sz="950" u="none">
+                  <a:defRPr b="0" i="0" strike="noStrike" sz="850" u="none">
                     <a:solidFill>
                       <a:srgbClr val="FFFFFF"/>
                     </a:solidFill>
@@ -1033,7 +1033,7 @@
               <a:lstStyle/>
               <a:p>
                 <a:pPr>
-                  <a:defRPr b="0" i="0" strike="noStrike" sz="950" u="none">
+                  <a:defRPr b="0" i="0" strike="noStrike" sz="850" u="none">
                     <a:solidFill>
                       <a:srgbClr val="FFFFFF"/>
                     </a:solidFill>
@@ -1084,7 +1084,7 @@
             <a:lstStyle/>
             <a:p>
               <a:pPr>
-                <a:defRPr b="0" i="0" strike="noStrike" sz="950" u="none">
+                <a:defRPr b="0" i="0" strike="noStrike" sz="850" u="none">
                   <a:solidFill>
                     <a:srgbClr val="FFFFFF"/>
                   </a:solidFill>
@@ -1207,24 +1207,6 @@
         <a:effectLst/>
       </c:spPr>
     </c:plotArea>
-    <c:legend>
-      <c:legendPos val="b"/>
-      <c:overlay val="0"/>
-      <c:txPr>
-        <a:bodyPr/>
-        <a:lstStyle/>
-        <a:p>
-          <a:pPr>
-            <a:defRPr sz="950">
-              <a:solidFill>
-                <a:srgbClr val="0B1B2B"/>
-              </a:solidFill>
-            </a:defRPr>
-          </a:pPr>
-          <a:endParaRPr lang="en-US"/>
-        </a:p>
-      </c:txPr>
-    </c:legend>
     <c:plotVisOnly val="1"/>
     <c:dispBlanksAs val="span"/>
   </c:chart>
@@ -11045,8 +11027,8 @@
         </p:nvSpPr>
         <p:spPr>
           <a:xfrm>
-            <a:off x="457200" y="4572000"/>
-            <a:ext cx="8229600" cy="256032"/>
+            <a:off x="457200" y="4389120"/>
+            <a:ext cx="8229600" cy="219456"/>
           </a:xfrm>
           <a:prstGeom prst="rect">
             <a:avLst/>
@@ -11083,8 +11065,8 @@
           <p:nvPr/>
         </p:nvGraphicFramePr>
         <p:xfrm>
-          <a:off x="457200" y="4864608"/>
-          <a:ext cx="11247120" cy="1051560"/>
+          <a:off x="457200" y="4645152"/>
+          <a:ext cx="11247120" cy="713232"/>
         </p:xfrm>
         <a:graphic xmlns:a="http://schemas.openxmlformats.org/drawingml/2006/main">
           <a:graphicData uri="http://schemas.openxmlformats.org/drawingml/2006/chart">
@@ -11092,16 +11074,1418 @@
           </a:graphicData>
         </a:graphic>
       </p:graphicFrame>
-      <p:sp>
-        <p:nvSpPr>
-          <p:cNvPr id="16" name="Text 11"/>
-          <p:cNvSpPr txBox="1"/>
-          <p:nvPr/>
-        </p:nvSpPr>
-        <p:spPr>
-          <a:xfrm>
-            <a:off x="457200" y="5989320"/>
-            <a:ext cx="11247120" cy="274320"/>
+      <p:graphicFrame>
+        <p:nvGraphicFramePr>
+          <p:cNvPr id="7" name="Table 0"/>
+          <p:cNvGraphicFramePr>
+            <a:graphicFrameLocks noGrp="1"/>
+          </p:cNvGraphicFramePr>
+          <p:nvPr>
+            <p:extLst>
+              <p:ext uri="{D42A27DB-BD31-4B8C-83A1-F6EECF244321}">
+                <p14:modId xmlns:p14="http://schemas.microsoft.com/office/powerpoint/2010/main" val="1579011935"/>
+              </p:ext>
+            </p:extLst>
+          </p:nvPr>
+        </p:nvGraphicFramePr>
+        <p:xfrm>
+          <a:off x="457200" y="5504688"/>
+          <a:ext cx="11247120" cy="777240"/>
+        </p:xfrm>
+        <a:graphic>
+          <a:graphicData uri="http://schemas.openxmlformats.org/drawingml/2006/table">
+            <a:tbl>
+              <a:tblPr/>
+              <a:tblGrid>
+                <a:gridCol w="4114800"/>
+                <a:gridCol w="2377440"/>
+                <a:gridCol w="2377440"/>
+                <a:gridCol w="2377440"/>
+              </a:tblGrid>
+              <a:tr h="155448">
+                <a:tc>
+                  <a:txBody>
+                    <a:bodyPr/>
+                    <a:lstStyle/>
+                    <a:p>
+                      <a:pPr algn="l" indent="0" marL="0">
+                        <a:buNone/>
+                      </a:pPr>
+                      <a:r>
+                        <a:rPr lang="en-US" sz="950" b="1" dirty="0">
+                          <a:solidFill>
+                            <a:srgbClr val="FFFFFF"/>
+                          </a:solidFill>
+                          <a:latin typeface="Calibri" pitchFamily="34" charset="0"/>
+                          <a:ea typeface="Calibri" pitchFamily="34" charset="-122"/>
+                          <a:cs typeface="Calibri" pitchFamily="34" charset="-120"/>
+                        </a:rPr>
+                        <a:t>Asset Class</a:t>
+                      </a:r>
+                      <a:endParaRPr lang="en-US" sz="950" dirty="0">
+                        <a:latin typeface="Calibri" charset="0"/>
+                        <a:ea typeface="Calibri" charset="0"/>
+                        <a:cs typeface="Calibri" charset="0"/>
+                      </a:endParaRPr>
+                    </a:p>
+                  </a:txBody>
+                  <a:tcPr marL="50800" marR="50800" marT="12700" marB="12700" anchor="ctr">
+                    <a:lnL w="12700" cap="flat" cmpd="sng" algn="ctr">
+                      <a:solidFill>
+                        <a:srgbClr val="E3DFD3"/>
+                      </a:solidFill>
+                      <a:prstDash val="solid"/>
+                      <a:round/>
+                      <a:headEnd type="none" w="med" len="med"/>
+                      <a:tailEnd type="none" w="med" len="med"/>
+                    </a:lnL>
+                    <a:lnR w="12700" cap="flat" cmpd="sng" algn="ctr">
+                      <a:solidFill>
+                        <a:srgbClr val="E3DFD3"/>
+                      </a:solidFill>
+                      <a:prstDash val="solid"/>
+                      <a:round/>
+                      <a:headEnd type="none" w="med" len="med"/>
+                      <a:tailEnd type="none" w="med" len="med"/>
+                    </a:lnR>
+                    <a:lnT w="12700" cap="flat" cmpd="sng" algn="ctr">
+                      <a:solidFill>
+                        <a:srgbClr val="E3DFD3"/>
+                      </a:solidFill>
+                      <a:prstDash val="solid"/>
+                      <a:round/>
+                      <a:headEnd type="none" w="med" len="med"/>
+                      <a:tailEnd type="none" w="med" len="med"/>
+                    </a:lnT>
+                    <a:lnB w="12700" cap="flat" cmpd="sng" algn="ctr">
+                      <a:solidFill>
+                        <a:srgbClr val="E3DFD3"/>
+                      </a:solidFill>
+                      <a:prstDash val="solid"/>
+                      <a:round/>
+                      <a:headEnd type="none" w="med" len="med"/>
+                      <a:tailEnd type="none" w="med" len="med"/>
+                    </a:lnB>
+                    <a:solidFill>
+                      <a:srgbClr val="0B1B2B"/>
+                    </a:solidFill>
+                  </a:tcPr>
+                </a:tc>
+                <a:tc>
+                  <a:txBody>
+                    <a:bodyPr/>
+                    <a:lstStyle/>
+                    <a:p>
+                      <a:pPr algn="l" indent="0" marL="0">
+                        <a:buNone/>
+                      </a:pPr>
+                      <a:r>
+                        <a:rPr lang="en-US" sz="950" b="1" dirty="0">
+                          <a:solidFill>
+                            <a:srgbClr val="FFFFFF"/>
+                          </a:solidFill>
+                          <a:latin typeface="Calibri" pitchFamily="34" charset="0"/>
+                          <a:ea typeface="Calibri" pitchFamily="34" charset="-122"/>
+                          <a:cs typeface="Calibri" pitchFamily="34" charset="-120"/>
+                        </a:rPr>
+                        <a:t>Weight</a:t>
+                      </a:r>
+                      <a:endParaRPr lang="en-US" sz="950" dirty="0">
+                        <a:latin typeface="Calibri" charset="0"/>
+                        <a:ea typeface="Calibri" charset="0"/>
+                        <a:cs typeface="Calibri" charset="0"/>
+                      </a:endParaRPr>
+                    </a:p>
+                  </a:txBody>
+                  <a:tcPr marL="50800" marR="50800" marT="12700" marB="12700" anchor="ctr">
+                    <a:lnL w="12700" cap="flat" cmpd="sng" algn="ctr">
+                      <a:solidFill>
+                        <a:srgbClr val="E3DFD3"/>
+                      </a:solidFill>
+                      <a:prstDash val="solid"/>
+                      <a:round/>
+                      <a:headEnd type="none" w="med" len="med"/>
+                      <a:tailEnd type="none" w="med" len="med"/>
+                    </a:lnL>
+                    <a:lnR w="12700" cap="flat" cmpd="sng" algn="ctr">
+                      <a:solidFill>
+                        <a:srgbClr val="E3DFD3"/>
+                      </a:solidFill>
+                      <a:prstDash val="solid"/>
+                      <a:round/>
+                      <a:headEnd type="none" w="med" len="med"/>
+                      <a:tailEnd type="none" w="med" len="med"/>
+                    </a:lnR>
+                    <a:lnT w="12700" cap="flat" cmpd="sng" algn="ctr">
+                      <a:solidFill>
+                        <a:srgbClr val="E3DFD3"/>
+                      </a:solidFill>
+                      <a:prstDash val="solid"/>
+                      <a:round/>
+                      <a:headEnd type="none" w="med" len="med"/>
+                      <a:tailEnd type="none" w="med" len="med"/>
+                    </a:lnT>
+                    <a:lnB w="12700" cap="flat" cmpd="sng" algn="ctr">
+                      <a:solidFill>
+                        <a:srgbClr val="E3DFD3"/>
+                      </a:solidFill>
+                      <a:prstDash val="solid"/>
+                      <a:round/>
+                      <a:headEnd type="none" w="med" len="med"/>
+                      <a:tailEnd type="none" w="med" len="med"/>
+                    </a:lnB>
+                    <a:solidFill>
+                      <a:srgbClr val="0B1B2B"/>
+                    </a:solidFill>
+                  </a:tcPr>
+                </a:tc>
+                <a:tc>
+                  <a:txBody>
+                    <a:bodyPr/>
+                    <a:lstStyle/>
+                    <a:p>
+                      <a:pPr algn="l" indent="0" marL="0">
+                        <a:buNone/>
+                      </a:pPr>
+                      <a:r>
+                        <a:rPr lang="en-US" sz="950" b="1" dirty="0">
+                          <a:solidFill>
+                            <a:srgbClr val="FFFFFF"/>
+                          </a:solidFill>
+                          <a:latin typeface="Calibri" pitchFamily="34" charset="0"/>
+                          <a:ea typeface="Calibri" pitchFamily="34" charset="-122"/>
+                          <a:cs typeface="Calibri" pitchFamily="34" charset="-120"/>
+                        </a:rPr>
+                        <a:t>Yield</a:t>
+                      </a:r>
+                      <a:endParaRPr lang="en-US" sz="950" dirty="0">
+                        <a:latin typeface="Calibri" charset="0"/>
+                        <a:ea typeface="Calibri" charset="0"/>
+                        <a:cs typeface="Calibri" charset="0"/>
+                      </a:endParaRPr>
+                    </a:p>
+                  </a:txBody>
+                  <a:tcPr marL="50800" marR="50800" marT="12700" marB="12700" anchor="ctr">
+                    <a:lnL w="12700" cap="flat" cmpd="sng" algn="ctr">
+                      <a:solidFill>
+                        <a:srgbClr val="E3DFD3"/>
+                      </a:solidFill>
+                      <a:prstDash val="solid"/>
+                      <a:round/>
+                      <a:headEnd type="none" w="med" len="med"/>
+                      <a:tailEnd type="none" w="med" len="med"/>
+                    </a:lnL>
+                    <a:lnR w="12700" cap="flat" cmpd="sng" algn="ctr">
+                      <a:solidFill>
+                        <a:srgbClr val="E3DFD3"/>
+                      </a:solidFill>
+                      <a:prstDash val="solid"/>
+                      <a:round/>
+                      <a:headEnd type="none" w="med" len="med"/>
+                      <a:tailEnd type="none" w="med" len="med"/>
+                    </a:lnR>
+                    <a:lnT w="12700" cap="flat" cmpd="sng" algn="ctr">
+                      <a:solidFill>
+                        <a:srgbClr val="E3DFD3"/>
+                      </a:solidFill>
+                      <a:prstDash val="solid"/>
+                      <a:round/>
+                      <a:headEnd type="none" w="med" len="med"/>
+                      <a:tailEnd type="none" w="med" len="med"/>
+                    </a:lnT>
+                    <a:lnB w="12700" cap="flat" cmpd="sng" algn="ctr">
+                      <a:solidFill>
+                        <a:srgbClr val="E3DFD3"/>
+                      </a:solidFill>
+                      <a:prstDash val="solid"/>
+                      <a:round/>
+                      <a:headEnd type="none" w="med" len="med"/>
+                      <a:tailEnd type="none" w="med" len="med"/>
+                    </a:lnB>
+                    <a:solidFill>
+                      <a:srgbClr val="0B1B2B"/>
+                    </a:solidFill>
+                  </a:tcPr>
+                </a:tc>
+                <a:tc>
+                  <a:txBody>
+                    <a:bodyPr/>
+                    <a:lstStyle/>
+                    <a:p>
+                      <a:pPr algn="l" indent="0" marL="0">
+                        <a:buNone/>
+                      </a:pPr>
+                      <a:r>
+                        <a:rPr lang="en-US" sz="950" b="1" dirty="0">
+                          <a:solidFill>
+                            <a:srgbClr val="FFFFFF"/>
+                          </a:solidFill>
+                          <a:latin typeface="Calibri" pitchFamily="34" charset="0"/>
+                          <a:ea typeface="Calibri" pitchFamily="34" charset="-122"/>
+                          <a:cs typeface="Calibri" pitchFamily="34" charset="-120"/>
+                        </a:rPr>
+                        <a:t>Total Return</a:t>
+                      </a:r>
+                      <a:endParaRPr lang="en-US" sz="950" dirty="0">
+                        <a:latin typeface="Calibri" charset="0"/>
+                        <a:ea typeface="Calibri" charset="0"/>
+                        <a:cs typeface="Calibri" charset="0"/>
+                      </a:endParaRPr>
+                    </a:p>
+                  </a:txBody>
+                  <a:tcPr marL="50800" marR="50800" marT="12700" marB="12700" anchor="ctr">
+                    <a:lnL w="12700" cap="flat" cmpd="sng" algn="ctr">
+                      <a:solidFill>
+                        <a:srgbClr val="E3DFD3"/>
+                      </a:solidFill>
+                      <a:prstDash val="solid"/>
+                      <a:round/>
+                      <a:headEnd type="none" w="med" len="med"/>
+                      <a:tailEnd type="none" w="med" len="med"/>
+                    </a:lnL>
+                    <a:lnR w="12700" cap="flat" cmpd="sng" algn="ctr">
+                      <a:solidFill>
+                        <a:srgbClr val="E3DFD3"/>
+                      </a:solidFill>
+                      <a:prstDash val="solid"/>
+                      <a:round/>
+                      <a:headEnd type="none" w="med" len="med"/>
+                      <a:tailEnd type="none" w="med" len="med"/>
+                    </a:lnR>
+                    <a:lnT w="12700" cap="flat" cmpd="sng" algn="ctr">
+                      <a:solidFill>
+                        <a:srgbClr val="E3DFD3"/>
+                      </a:solidFill>
+                      <a:prstDash val="solid"/>
+                      <a:round/>
+                      <a:headEnd type="none" w="med" len="med"/>
+                      <a:tailEnd type="none" w="med" len="med"/>
+                    </a:lnT>
+                    <a:lnB w="12700" cap="flat" cmpd="sng" algn="ctr">
+                      <a:solidFill>
+                        <a:srgbClr val="E3DFD3"/>
+                      </a:solidFill>
+                      <a:prstDash val="solid"/>
+                      <a:round/>
+                      <a:headEnd type="none" w="med" len="med"/>
+                      <a:tailEnd type="none" w="med" len="med"/>
+                    </a:lnB>
+                    <a:solidFill>
+                      <a:srgbClr val="0B1B2B"/>
+                    </a:solidFill>
+                  </a:tcPr>
+                </a:tc>
+              </a:tr>
+              <a:tr h="155448">
+                <a:tc>
+                  <a:txBody>
+                    <a:bodyPr/>
+                    <a:lstStyle/>
+                    <a:p>
+                      <a:pPr algn="l" indent="0" marL="0">
+                        <a:buNone/>
+                      </a:pPr>
+                      <a:r>
+                        <a:rPr lang="en-US" sz="900" dirty="0">
+                          <a:solidFill>
+                            <a:srgbClr val="0B1B2B"/>
+                          </a:solidFill>
+                          <a:latin typeface="Calibri" pitchFamily="34" charset="0"/>
+                          <a:ea typeface="Calibri" pitchFamily="34" charset="-122"/>
+                          <a:cs typeface="Calibri" pitchFamily="34" charset="-120"/>
+                        </a:rPr>
+                        <a:t>Equities</a:t>
+                      </a:r>
+                      <a:endParaRPr lang="en-US" sz="900" dirty="0">
+                        <a:latin typeface="Calibri" charset="0"/>
+                        <a:ea typeface="Calibri" charset="0"/>
+                        <a:cs typeface="Calibri" charset="0"/>
+                      </a:endParaRPr>
+                    </a:p>
+                  </a:txBody>
+                  <a:tcPr marL="50800" marR="50800" marT="12700" marB="12700" anchor="ctr">
+                    <a:lnL w="12700" cap="flat" cmpd="sng" algn="ctr">
+                      <a:solidFill>
+                        <a:srgbClr val="E3DFD3"/>
+                      </a:solidFill>
+                      <a:prstDash val="solid"/>
+                      <a:round/>
+                      <a:headEnd type="none" w="med" len="med"/>
+                      <a:tailEnd type="none" w="med" len="med"/>
+                    </a:lnL>
+                    <a:lnR w="12700" cap="flat" cmpd="sng" algn="ctr">
+                      <a:solidFill>
+                        <a:srgbClr val="E3DFD3"/>
+                      </a:solidFill>
+                      <a:prstDash val="solid"/>
+                      <a:round/>
+                      <a:headEnd type="none" w="med" len="med"/>
+                      <a:tailEnd type="none" w="med" len="med"/>
+                    </a:lnR>
+                    <a:lnT w="12700" cap="flat" cmpd="sng" algn="ctr">
+                      <a:solidFill>
+                        <a:srgbClr val="E3DFD3"/>
+                      </a:solidFill>
+                      <a:prstDash val="solid"/>
+                      <a:round/>
+                      <a:headEnd type="none" w="med" len="med"/>
+                      <a:tailEnd type="none" w="med" len="med"/>
+                    </a:lnT>
+                    <a:lnB w="12700" cap="flat" cmpd="sng" algn="ctr">
+                      <a:solidFill>
+                        <a:srgbClr val="E3DFD3"/>
+                      </a:solidFill>
+                      <a:prstDash val="solid"/>
+                      <a:round/>
+                      <a:headEnd type="none" w="med" len="med"/>
+                      <a:tailEnd type="none" w="med" len="med"/>
+                    </a:lnB>
+                    <a:solidFill>
+                      <a:srgbClr val="FFFFFF"/>
+                    </a:solidFill>
+                  </a:tcPr>
+                </a:tc>
+                <a:tc>
+                  <a:txBody>
+                    <a:bodyPr/>
+                    <a:lstStyle/>
+                    <a:p>
+                      <a:pPr algn="l" indent="0" marL="0">
+                        <a:buNone/>
+                      </a:pPr>
+                      <a:r>
+                        <a:rPr lang="en-US" sz="900" dirty="0">
+                          <a:solidFill>
+                            <a:srgbClr val="0B1B2B"/>
+                          </a:solidFill>
+                          <a:latin typeface="Calibri" pitchFamily="34" charset="0"/>
+                          <a:ea typeface="Calibri" pitchFamily="34" charset="-122"/>
+                          <a:cs typeface="Calibri" pitchFamily="34" charset="-120"/>
+                        </a:rPr>
+                        <a:t>50%</a:t>
+                      </a:r>
+                      <a:endParaRPr lang="en-US" sz="900" dirty="0">
+                        <a:latin typeface="Calibri" charset="0"/>
+                        <a:ea typeface="Calibri" charset="0"/>
+                        <a:cs typeface="Calibri" charset="0"/>
+                      </a:endParaRPr>
+                    </a:p>
+                  </a:txBody>
+                  <a:tcPr marL="50800" marR="50800" marT="12700" marB="12700" anchor="ctr">
+                    <a:lnL w="12700" cap="flat" cmpd="sng" algn="ctr">
+                      <a:solidFill>
+                        <a:srgbClr val="E3DFD3"/>
+                      </a:solidFill>
+                      <a:prstDash val="solid"/>
+                      <a:round/>
+                      <a:headEnd type="none" w="med" len="med"/>
+                      <a:tailEnd type="none" w="med" len="med"/>
+                    </a:lnL>
+                    <a:lnR w="12700" cap="flat" cmpd="sng" algn="ctr">
+                      <a:solidFill>
+                        <a:srgbClr val="E3DFD3"/>
+                      </a:solidFill>
+                      <a:prstDash val="solid"/>
+                      <a:round/>
+                      <a:headEnd type="none" w="med" len="med"/>
+                      <a:tailEnd type="none" w="med" len="med"/>
+                    </a:lnR>
+                    <a:lnT w="12700" cap="flat" cmpd="sng" algn="ctr">
+                      <a:solidFill>
+                        <a:srgbClr val="E3DFD3"/>
+                      </a:solidFill>
+                      <a:prstDash val="solid"/>
+                      <a:round/>
+                      <a:headEnd type="none" w="med" len="med"/>
+                      <a:tailEnd type="none" w="med" len="med"/>
+                    </a:lnT>
+                    <a:lnB w="12700" cap="flat" cmpd="sng" algn="ctr">
+                      <a:solidFill>
+                        <a:srgbClr val="E3DFD3"/>
+                      </a:solidFill>
+                      <a:prstDash val="solid"/>
+                      <a:round/>
+                      <a:headEnd type="none" w="med" len="med"/>
+                      <a:tailEnd type="none" w="med" len="med"/>
+                    </a:lnB>
+                    <a:solidFill>
+                      <a:srgbClr val="FFFFFF"/>
+                    </a:solidFill>
+                  </a:tcPr>
+                </a:tc>
+                <a:tc>
+                  <a:txBody>
+                    <a:bodyPr/>
+                    <a:lstStyle/>
+                    <a:p>
+                      <a:pPr algn="l" indent="0" marL="0">
+                        <a:buNone/>
+                      </a:pPr>
+                      <a:r>
+                        <a:rPr lang="en-US" sz="900" dirty="0">
+                          <a:solidFill>
+                            <a:srgbClr val="0B1B2B"/>
+                          </a:solidFill>
+                          <a:latin typeface="Calibri" pitchFamily="34" charset="0"/>
+                          <a:ea typeface="Calibri" pitchFamily="34" charset="-122"/>
+                          <a:cs typeface="Calibri" pitchFamily="34" charset="-120"/>
+                        </a:rPr>
+                        <a:t>2.5%</a:t>
+                      </a:r>
+                      <a:endParaRPr lang="en-US" sz="900" dirty="0">
+                        <a:latin typeface="Calibri" charset="0"/>
+                        <a:ea typeface="Calibri" charset="0"/>
+                        <a:cs typeface="Calibri" charset="0"/>
+                      </a:endParaRPr>
+                    </a:p>
+                  </a:txBody>
+                  <a:tcPr marL="50800" marR="50800" marT="12700" marB="12700" anchor="ctr">
+                    <a:lnL w="12700" cap="flat" cmpd="sng" algn="ctr">
+                      <a:solidFill>
+                        <a:srgbClr val="E3DFD3"/>
+                      </a:solidFill>
+                      <a:prstDash val="solid"/>
+                      <a:round/>
+                      <a:headEnd type="none" w="med" len="med"/>
+                      <a:tailEnd type="none" w="med" len="med"/>
+                    </a:lnL>
+                    <a:lnR w="12700" cap="flat" cmpd="sng" algn="ctr">
+                      <a:solidFill>
+                        <a:srgbClr val="E3DFD3"/>
+                      </a:solidFill>
+                      <a:prstDash val="solid"/>
+                      <a:round/>
+                      <a:headEnd type="none" w="med" len="med"/>
+                      <a:tailEnd type="none" w="med" len="med"/>
+                    </a:lnR>
+                    <a:lnT w="12700" cap="flat" cmpd="sng" algn="ctr">
+                      <a:solidFill>
+                        <a:srgbClr val="E3DFD3"/>
+                      </a:solidFill>
+                      <a:prstDash val="solid"/>
+                      <a:round/>
+                      <a:headEnd type="none" w="med" len="med"/>
+                      <a:tailEnd type="none" w="med" len="med"/>
+                    </a:lnT>
+                    <a:lnB w="12700" cap="flat" cmpd="sng" algn="ctr">
+                      <a:solidFill>
+                        <a:srgbClr val="E3DFD3"/>
+                      </a:solidFill>
+                      <a:prstDash val="solid"/>
+                      <a:round/>
+                      <a:headEnd type="none" w="med" len="med"/>
+                      <a:tailEnd type="none" w="med" len="med"/>
+                    </a:lnB>
+                    <a:solidFill>
+                      <a:srgbClr val="FFFFFF"/>
+                    </a:solidFill>
+                  </a:tcPr>
+                </a:tc>
+                <a:tc>
+                  <a:txBody>
+                    <a:bodyPr/>
+                    <a:lstStyle/>
+                    <a:p>
+                      <a:pPr algn="l" indent="0" marL="0">
+                        <a:buNone/>
+                      </a:pPr>
+                      <a:r>
+                        <a:rPr lang="en-US" sz="900" dirty="0">
+                          <a:solidFill>
+                            <a:srgbClr val="0B1B2B"/>
+                          </a:solidFill>
+                          <a:latin typeface="Calibri" pitchFamily="34" charset="0"/>
+                          <a:ea typeface="Calibri" pitchFamily="34" charset="-122"/>
+                          <a:cs typeface="Calibri" pitchFamily="34" charset="-120"/>
+                        </a:rPr>
+                        <a:t>9.0%</a:t>
+                      </a:r>
+                      <a:endParaRPr lang="en-US" sz="900" dirty="0">
+                        <a:latin typeface="Calibri" charset="0"/>
+                        <a:ea typeface="Calibri" charset="0"/>
+                        <a:cs typeface="Calibri" charset="0"/>
+                      </a:endParaRPr>
+                    </a:p>
+                  </a:txBody>
+                  <a:tcPr marL="50800" marR="50800" marT="12700" marB="12700" anchor="ctr">
+                    <a:lnL w="12700" cap="flat" cmpd="sng" algn="ctr">
+                      <a:solidFill>
+                        <a:srgbClr val="E3DFD3"/>
+                      </a:solidFill>
+                      <a:prstDash val="solid"/>
+                      <a:round/>
+                      <a:headEnd type="none" w="med" len="med"/>
+                      <a:tailEnd type="none" w="med" len="med"/>
+                    </a:lnL>
+                    <a:lnR w="12700" cap="flat" cmpd="sng" algn="ctr">
+                      <a:solidFill>
+                        <a:srgbClr val="E3DFD3"/>
+                      </a:solidFill>
+                      <a:prstDash val="solid"/>
+                      <a:round/>
+                      <a:headEnd type="none" w="med" len="med"/>
+                      <a:tailEnd type="none" w="med" len="med"/>
+                    </a:lnR>
+                    <a:lnT w="12700" cap="flat" cmpd="sng" algn="ctr">
+                      <a:solidFill>
+                        <a:srgbClr val="E3DFD3"/>
+                      </a:solidFill>
+                      <a:prstDash val="solid"/>
+                      <a:round/>
+                      <a:headEnd type="none" w="med" len="med"/>
+                      <a:tailEnd type="none" w="med" len="med"/>
+                    </a:lnT>
+                    <a:lnB w="12700" cap="flat" cmpd="sng" algn="ctr">
+                      <a:solidFill>
+                        <a:srgbClr val="E3DFD3"/>
+                      </a:solidFill>
+                      <a:prstDash val="solid"/>
+                      <a:round/>
+                      <a:headEnd type="none" w="med" len="med"/>
+                      <a:tailEnd type="none" w="med" len="med"/>
+                    </a:lnB>
+                    <a:solidFill>
+                      <a:srgbClr val="FFFFFF"/>
+                    </a:solidFill>
+                  </a:tcPr>
+                </a:tc>
+              </a:tr>
+              <a:tr h="155448">
+                <a:tc>
+                  <a:txBody>
+                    <a:bodyPr/>
+                    <a:lstStyle/>
+                    <a:p>
+                      <a:pPr algn="l" indent="0" marL="0">
+                        <a:buNone/>
+                      </a:pPr>
+                      <a:r>
+                        <a:rPr lang="en-US" sz="900" dirty="0">
+                          <a:solidFill>
+                            <a:srgbClr val="0B1B2B"/>
+                          </a:solidFill>
+                          <a:latin typeface="Calibri" pitchFamily="34" charset="0"/>
+                          <a:ea typeface="Calibri" pitchFamily="34" charset="-122"/>
+                          <a:cs typeface="Calibri" pitchFamily="34" charset="-120"/>
+                        </a:rPr>
+                        <a:t>Bonds &amp; Credit</a:t>
+                      </a:r>
+                      <a:endParaRPr lang="en-US" sz="900" dirty="0">
+                        <a:latin typeface="Calibri" charset="0"/>
+                        <a:ea typeface="Calibri" charset="0"/>
+                        <a:cs typeface="Calibri" charset="0"/>
+                      </a:endParaRPr>
+                    </a:p>
+                  </a:txBody>
+                  <a:tcPr marL="50800" marR="50800" marT="12700" marB="12700" anchor="ctr">
+                    <a:lnL w="12700" cap="flat" cmpd="sng" algn="ctr">
+                      <a:solidFill>
+                        <a:srgbClr val="E3DFD3"/>
+                      </a:solidFill>
+                      <a:prstDash val="solid"/>
+                      <a:round/>
+                      <a:headEnd type="none" w="med" len="med"/>
+                      <a:tailEnd type="none" w="med" len="med"/>
+                    </a:lnL>
+                    <a:lnR w="12700" cap="flat" cmpd="sng" algn="ctr">
+                      <a:solidFill>
+                        <a:srgbClr val="E3DFD3"/>
+                      </a:solidFill>
+                      <a:prstDash val="solid"/>
+                      <a:round/>
+                      <a:headEnd type="none" w="med" len="med"/>
+                      <a:tailEnd type="none" w="med" len="med"/>
+                    </a:lnR>
+                    <a:lnT w="12700" cap="flat" cmpd="sng" algn="ctr">
+                      <a:solidFill>
+                        <a:srgbClr val="E3DFD3"/>
+                      </a:solidFill>
+                      <a:prstDash val="solid"/>
+                      <a:round/>
+                      <a:headEnd type="none" w="med" len="med"/>
+                      <a:tailEnd type="none" w="med" len="med"/>
+                    </a:lnT>
+                    <a:lnB w="12700" cap="flat" cmpd="sng" algn="ctr">
+                      <a:solidFill>
+                        <a:srgbClr val="E3DFD3"/>
+                      </a:solidFill>
+                      <a:prstDash val="solid"/>
+                      <a:round/>
+                      <a:headEnd type="none" w="med" len="med"/>
+                      <a:tailEnd type="none" w="med" len="med"/>
+                    </a:lnB>
+                    <a:solidFill>
+                      <a:srgbClr val="F6F3EC"/>
+                    </a:solidFill>
+                  </a:tcPr>
+                </a:tc>
+                <a:tc>
+                  <a:txBody>
+                    <a:bodyPr/>
+                    <a:lstStyle/>
+                    <a:p>
+                      <a:pPr algn="l" indent="0" marL="0">
+                        <a:buNone/>
+                      </a:pPr>
+                      <a:r>
+                        <a:rPr lang="en-US" sz="900" dirty="0">
+                          <a:solidFill>
+                            <a:srgbClr val="0B1B2B"/>
+                          </a:solidFill>
+                          <a:latin typeface="Calibri" pitchFamily="34" charset="0"/>
+                          <a:ea typeface="Calibri" pitchFamily="34" charset="-122"/>
+                          <a:cs typeface="Calibri" pitchFamily="34" charset="-120"/>
+                        </a:rPr>
+                        <a:t>20%</a:t>
+                      </a:r>
+                      <a:endParaRPr lang="en-US" sz="900" dirty="0">
+                        <a:latin typeface="Calibri" charset="0"/>
+                        <a:ea typeface="Calibri" charset="0"/>
+                        <a:cs typeface="Calibri" charset="0"/>
+                      </a:endParaRPr>
+                    </a:p>
+                  </a:txBody>
+                  <a:tcPr marL="50800" marR="50800" marT="12700" marB="12700" anchor="ctr">
+                    <a:lnL w="12700" cap="flat" cmpd="sng" algn="ctr">
+                      <a:solidFill>
+                        <a:srgbClr val="E3DFD3"/>
+                      </a:solidFill>
+                      <a:prstDash val="solid"/>
+                      <a:round/>
+                      <a:headEnd type="none" w="med" len="med"/>
+                      <a:tailEnd type="none" w="med" len="med"/>
+                    </a:lnL>
+                    <a:lnR w="12700" cap="flat" cmpd="sng" algn="ctr">
+                      <a:solidFill>
+                        <a:srgbClr val="E3DFD3"/>
+                      </a:solidFill>
+                      <a:prstDash val="solid"/>
+                      <a:round/>
+                      <a:headEnd type="none" w="med" len="med"/>
+                      <a:tailEnd type="none" w="med" len="med"/>
+                    </a:lnR>
+                    <a:lnT w="12700" cap="flat" cmpd="sng" algn="ctr">
+                      <a:solidFill>
+                        <a:srgbClr val="E3DFD3"/>
+                      </a:solidFill>
+                      <a:prstDash val="solid"/>
+                      <a:round/>
+                      <a:headEnd type="none" w="med" len="med"/>
+                      <a:tailEnd type="none" w="med" len="med"/>
+                    </a:lnT>
+                    <a:lnB w="12700" cap="flat" cmpd="sng" algn="ctr">
+                      <a:solidFill>
+                        <a:srgbClr val="E3DFD3"/>
+                      </a:solidFill>
+                      <a:prstDash val="solid"/>
+                      <a:round/>
+                      <a:headEnd type="none" w="med" len="med"/>
+                      <a:tailEnd type="none" w="med" len="med"/>
+                    </a:lnB>
+                    <a:solidFill>
+                      <a:srgbClr val="F6F3EC"/>
+                    </a:solidFill>
+                  </a:tcPr>
+                </a:tc>
+                <a:tc>
+                  <a:txBody>
+                    <a:bodyPr/>
+                    <a:lstStyle/>
+                    <a:p>
+                      <a:pPr algn="l" indent="0" marL="0">
+                        <a:buNone/>
+                      </a:pPr>
+                      <a:r>
+                        <a:rPr lang="en-US" sz="900" dirty="0">
+                          <a:solidFill>
+                            <a:srgbClr val="0B1B2B"/>
+                          </a:solidFill>
+                          <a:latin typeface="Calibri" pitchFamily="34" charset="0"/>
+                          <a:ea typeface="Calibri" pitchFamily="34" charset="-122"/>
+                          <a:cs typeface="Calibri" pitchFamily="34" charset="-120"/>
+                        </a:rPr>
+                        <a:t>4.5%</a:t>
+                      </a:r>
+                      <a:endParaRPr lang="en-US" sz="900" dirty="0">
+                        <a:latin typeface="Calibri" charset="0"/>
+                        <a:ea typeface="Calibri" charset="0"/>
+                        <a:cs typeface="Calibri" charset="0"/>
+                      </a:endParaRPr>
+                    </a:p>
+                  </a:txBody>
+                  <a:tcPr marL="50800" marR="50800" marT="12700" marB="12700" anchor="ctr">
+                    <a:lnL w="12700" cap="flat" cmpd="sng" algn="ctr">
+                      <a:solidFill>
+                        <a:srgbClr val="E3DFD3"/>
+                      </a:solidFill>
+                      <a:prstDash val="solid"/>
+                      <a:round/>
+                      <a:headEnd type="none" w="med" len="med"/>
+                      <a:tailEnd type="none" w="med" len="med"/>
+                    </a:lnL>
+                    <a:lnR w="12700" cap="flat" cmpd="sng" algn="ctr">
+                      <a:solidFill>
+                        <a:srgbClr val="E3DFD3"/>
+                      </a:solidFill>
+                      <a:prstDash val="solid"/>
+                      <a:round/>
+                      <a:headEnd type="none" w="med" len="med"/>
+                      <a:tailEnd type="none" w="med" len="med"/>
+                    </a:lnR>
+                    <a:lnT w="12700" cap="flat" cmpd="sng" algn="ctr">
+                      <a:solidFill>
+                        <a:srgbClr val="E3DFD3"/>
+                      </a:solidFill>
+                      <a:prstDash val="solid"/>
+                      <a:round/>
+                      <a:headEnd type="none" w="med" len="med"/>
+                      <a:tailEnd type="none" w="med" len="med"/>
+                    </a:lnT>
+                    <a:lnB w="12700" cap="flat" cmpd="sng" algn="ctr">
+                      <a:solidFill>
+                        <a:srgbClr val="E3DFD3"/>
+                      </a:solidFill>
+                      <a:prstDash val="solid"/>
+                      <a:round/>
+                      <a:headEnd type="none" w="med" len="med"/>
+                      <a:tailEnd type="none" w="med" len="med"/>
+                    </a:lnB>
+                    <a:solidFill>
+                      <a:srgbClr val="F6F3EC"/>
+                    </a:solidFill>
+                  </a:tcPr>
+                </a:tc>
+                <a:tc>
+                  <a:txBody>
+                    <a:bodyPr/>
+                    <a:lstStyle/>
+                    <a:p>
+                      <a:pPr algn="l" indent="0" marL="0">
+                        <a:buNone/>
+                      </a:pPr>
+                      <a:r>
+                        <a:rPr lang="en-US" sz="900" dirty="0">
+                          <a:solidFill>
+                            <a:srgbClr val="0B1B2B"/>
+                          </a:solidFill>
+                          <a:latin typeface="Calibri" pitchFamily="34" charset="0"/>
+                          <a:ea typeface="Calibri" pitchFamily="34" charset="-122"/>
+                          <a:cs typeface="Calibri" pitchFamily="34" charset="-120"/>
+                        </a:rPr>
+                        <a:t>5.0%</a:t>
+                      </a:r>
+                      <a:endParaRPr lang="en-US" sz="900" dirty="0">
+                        <a:latin typeface="Calibri" charset="0"/>
+                        <a:ea typeface="Calibri" charset="0"/>
+                        <a:cs typeface="Calibri" charset="0"/>
+                      </a:endParaRPr>
+                    </a:p>
+                  </a:txBody>
+                  <a:tcPr marL="50800" marR="50800" marT="12700" marB="12700" anchor="ctr">
+                    <a:lnL w="12700" cap="flat" cmpd="sng" algn="ctr">
+                      <a:solidFill>
+                        <a:srgbClr val="E3DFD3"/>
+                      </a:solidFill>
+                      <a:prstDash val="solid"/>
+                      <a:round/>
+                      <a:headEnd type="none" w="med" len="med"/>
+                      <a:tailEnd type="none" w="med" len="med"/>
+                    </a:lnL>
+                    <a:lnR w="12700" cap="flat" cmpd="sng" algn="ctr">
+                      <a:solidFill>
+                        <a:srgbClr val="E3DFD3"/>
+                      </a:solidFill>
+                      <a:prstDash val="solid"/>
+                      <a:round/>
+                      <a:headEnd type="none" w="med" len="med"/>
+                      <a:tailEnd type="none" w="med" len="med"/>
+                    </a:lnR>
+                    <a:lnT w="12700" cap="flat" cmpd="sng" algn="ctr">
+                      <a:solidFill>
+                        <a:srgbClr val="E3DFD3"/>
+                      </a:solidFill>
+                      <a:prstDash val="solid"/>
+                      <a:round/>
+                      <a:headEnd type="none" w="med" len="med"/>
+                      <a:tailEnd type="none" w="med" len="med"/>
+                    </a:lnT>
+                    <a:lnB w="12700" cap="flat" cmpd="sng" algn="ctr">
+                      <a:solidFill>
+                        <a:srgbClr val="E3DFD3"/>
+                      </a:solidFill>
+                      <a:prstDash val="solid"/>
+                      <a:round/>
+                      <a:headEnd type="none" w="med" len="med"/>
+                      <a:tailEnd type="none" w="med" len="med"/>
+                    </a:lnB>
+                    <a:solidFill>
+                      <a:srgbClr val="F6F3EC"/>
+                    </a:solidFill>
+                  </a:tcPr>
+                </a:tc>
+              </a:tr>
+              <a:tr h="155448">
+                <a:tc>
+                  <a:txBody>
+                    <a:bodyPr/>
+                    <a:lstStyle/>
+                    <a:p>
+                      <a:pPr algn="l" indent="0" marL="0">
+                        <a:buNone/>
+                      </a:pPr>
+                      <a:r>
+                        <a:rPr lang="en-US" sz="900" dirty="0">
+                          <a:solidFill>
+                            <a:srgbClr val="0B1B2B"/>
+                          </a:solidFill>
+                          <a:latin typeface="Calibri" pitchFamily="34" charset="0"/>
+                          <a:ea typeface="Calibri" pitchFamily="34" charset="-122"/>
+                          <a:cs typeface="Calibri" pitchFamily="34" charset="-120"/>
+                        </a:rPr>
+                        <a:t>Alternatives</a:t>
+                      </a:r>
+                      <a:endParaRPr lang="en-US" sz="900" dirty="0">
+                        <a:latin typeface="Calibri" charset="0"/>
+                        <a:ea typeface="Calibri" charset="0"/>
+                        <a:cs typeface="Calibri" charset="0"/>
+                      </a:endParaRPr>
+                    </a:p>
+                  </a:txBody>
+                  <a:tcPr marL="50800" marR="50800" marT="12700" marB="12700" anchor="ctr">
+                    <a:lnL w="12700" cap="flat" cmpd="sng" algn="ctr">
+                      <a:solidFill>
+                        <a:srgbClr val="E3DFD3"/>
+                      </a:solidFill>
+                      <a:prstDash val="solid"/>
+                      <a:round/>
+                      <a:headEnd type="none" w="med" len="med"/>
+                      <a:tailEnd type="none" w="med" len="med"/>
+                    </a:lnL>
+                    <a:lnR w="12700" cap="flat" cmpd="sng" algn="ctr">
+                      <a:solidFill>
+                        <a:srgbClr val="E3DFD3"/>
+                      </a:solidFill>
+                      <a:prstDash val="solid"/>
+                      <a:round/>
+                      <a:headEnd type="none" w="med" len="med"/>
+                      <a:tailEnd type="none" w="med" len="med"/>
+                    </a:lnR>
+                    <a:lnT w="12700" cap="flat" cmpd="sng" algn="ctr">
+                      <a:solidFill>
+                        <a:srgbClr val="E3DFD3"/>
+                      </a:solidFill>
+                      <a:prstDash val="solid"/>
+                      <a:round/>
+                      <a:headEnd type="none" w="med" len="med"/>
+                      <a:tailEnd type="none" w="med" len="med"/>
+                    </a:lnT>
+                    <a:lnB w="12700" cap="flat" cmpd="sng" algn="ctr">
+                      <a:solidFill>
+                        <a:srgbClr val="E3DFD3"/>
+                      </a:solidFill>
+                      <a:prstDash val="solid"/>
+                      <a:round/>
+                      <a:headEnd type="none" w="med" len="med"/>
+                      <a:tailEnd type="none" w="med" len="med"/>
+                    </a:lnB>
+                    <a:solidFill>
+                      <a:srgbClr val="FFFFFF"/>
+                    </a:solidFill>
+                  </a:tcPr>
+                </a:tc>
+                <a:tc>
+                  <a:txBody>
+                    <a:bodyPr/>
+                    <a:lstStyle/>
+                    <a:p>
+                      <a:pPr algn="l" indent="0" marL="0">
+                        <a:buNone/>
+                      </a:pPr>
+                      <a:r>
+                        <a:rPr lang="en-US" sz="900" dirty="0">
+                          <a:solidFill>
+                            <a:srgbClr val="0B1B2B"/>
+                          </a:solidFill>
+                          <a:latin typeface="Calibri" pitchFamily="34" charset="0"/>
+                          <a:ea typeface="Calibri" pitchFamily="34" charset="-122"/>
+                          <a:cs typeface="Calibri" pitchFamily="34" charset="-120"/>
+                        </a:rPr>
+                        <a:t>20%</a:t>
+                      </a:r>
+                      <a:endParaRPr lang="en-US" sz="900" dirty="0">
+                        <a:latin typeface="Calibri" charset="0"/>
+                        <a:ea typeface="Calibri" charset="0"/>
+                        <a:cs typeface="Calibri" charset="0"/>
+                      </a:endParaRPr>
+                    </a:p>
+                  </a:txBody>
+                  <a:tcPr marL="50800" marR="50800" marT="12700" marB="12700" anchor="ctr">
+                    <a:lnL w="12700" cap="flat" cmpd="sng" algn="ctr">
+                      <a:solidFill>
+                        <a:srgbClr val="E3DFD3"/>
+                      </a:solidFill>
+                      <a:prstDash val="solid"/>
+                      <a:round/>
+                      <a:headEnd type="none" w="med" len="med"/>
+                      <a:tailEnd type="none" w="med" len="med"/>
+                    </a:lnL>
+                    <a:lnR w="12700" cap="flat" cmpd="sng" algn="ctr">
+                      <a:solidFill>
+                        <a:srgbClr val="E3DFD3"/>
+                      </a:solidFill>
+                      <a:prstDash val="solid"/>
+                      <a:round/>
+                      <a:headEnd type="none" w="med" len="med"/>
+                      <a:tailEnd type="none" w="med" len="med"/>
+                    </a:lnR>
+                    <a:lnT w="12700" cap="flat" cmpd="sng" algn="ctr">
+                      <a:solidFill>
+                        <a:srgbClr val="E3DFD3"/>
+                      </a:solidFill>
+                      <a:prstDash val="solid"/>
+                      <a:round/>
+                      <a:headEnd type="none" w="med" len="med"/>
+                      <a:tailEnd type="none" w="med" len="med"/>
+                    </a:lnT>
+                    <a:lnB w="12700" cap="flat" cmpd="sng" algn="ctr">
+                      <a:solidFill>
+                        <a:srgbClr val="E3DFD3"/>
+                      </a:solidFill>
+                      <a:prstDash val="solid"/>
+                      <a:round/>
+                      <a:headEnd type="none" w="med" len="med"/>
+                      <a:tailEnd type="none" w="med" len="med"/>
+                    </a:lnB>
+                    <a:solidFill>
+                      <a:srgbClr val="FFFFFF"/>
+                    </a:solidFill>
+                  </a:tcPr>
+                </a:tc>
+                <a:tc>
+                  <a:txBody>
+                    <a:bodyPr/>
+                    <a:lstStyle/>
+                    <a:p>
+                      <a:pPr algn="l" indent="0" marL="0">
+                        <a:buNone/>
+                      </a:pPr>
+                      <a:r>
+                        <a:rPr lang="en-US" sz="900" dirty="0">
+                          <a:solidFill>
+                            <a:srgbClr val="0B1B2B"/>
+                          </a:solidFill>
+                          <a:latin typeface="Calibri" pitchFamily="34" charset="0"/>
+                          <a:ea typeface="Calibri" pitchFamily="34" charset="-122"/>
+                          <a:cs typeface="Calibri" pitchFamily="34" charset="-120"/>
+                        </a:rPr>
+                        <a:t>4.0%</a:t>
+                      </a:r>
+                      <a:endParaRPr lang="en-US" sz="900" dirty="0">
+                        <a:latin typeface="Calibri" charset="0"/>
+                        <a:ea typeface="Calibri" charset="0"/>
+                        <a:cs typeface="Calibri" charset="0"/>
+                      </a:endParaRPr>
+                    </a:p>
+                  </a:txBody>
+                  <a:tcPr marL="50800" marR="50800" marT="12700" marB="12700" anchor="ctr">
+                    <a:lnL w="12700" cap="flat" cmpd="sng" algn="ctr">
+                      <a:solidFill>
+                        <a:srgbClr val="E3DFD3"/>
+                      </a:solidFill>
+                      <a:prstDash val="solid"/>
+                      <a:round/>
+                      <a:headEnd type="none" w="med" len="med"/>
+                      <a:tailEnd type="none" w="med" len="med"/>
+                    </a:lnL>
+                    <a:lnR w="12700" cap="flat" cmpd="sng" algn="ctr">
+                      <a:solidFill>
+                        <a:srgbClr val="E3DFD3"/>
+                      </a:solidFill>
+                      <a:prstDash val="solid"/>
+                      <a:round/>
+                      <a:headEnd type="none" w="med" len="med"/>
+                      <a:tailEnd type="none" w="med" len="med"/>
+                    </a:lnR>
+                    <a:lnT w="12700" cap="flat" cmpd="sng" algn="ctr">
+                      <a:solidFill>
+                        <a:srgbClr val="E3DFD3"/>
+                      </a:solidFill>
+                      <a:prstDash val="solid"/>
+                      <a:round/>
+                      <a:headEnd type="none" w="med" len="med"/>
+                      <a:tailEnd type="none" w="med" len="med"/>
+                    </a:lnT>
+                    <a:lnB w="12700" cap="flat" cmpd="sng" algn="ctr">
+                      <a:solidFill>
+                        <a:srgbClr val="E3DFD3"/>
+                      </a:solidFill>
+                      <a:prstDash val="solid"/>
+                      <a:round/>
+                      <a:headEnd type="none" w="med" len="med"/>
+                      <a:tailEnd type="none" w="med" len="med"/>
+                    </a:lnB>
+                    <a:solidFill>
+                      <a:srgbClr val="FFFFFF"/>
+                    </a:solidFill>
+                  </a:tcPr>
+                </a:tc>
+                <a:tc>
+                  <a:txBody>
+                    <a:bodyPr/>
+                    <a:lstStyle/>
+                    <a:p>
+                      <a:pPr algn="l" indent="0" marL="0">
+                        <a:buNone/>
+                      </a:pPr>
+                      <a:r>
+                        <a:rPr lang="en-US" sz="900" dirty="0">
+                          <a:solidFill>
+                            <a:srgbClr val="0B1B2B"/>
+                          </a:solidFill>
+                          <a:latin typeface="Calibri" pitchFamily="34" charset="0"/>
+                          <a:ea typeface="Calibri" pitchFamily="34" charset="-122"/>
+                          <a:cs typeface="Calibri" pitchFamily="34" charset="-120"/>
+                        </a:rPr>
+                        <a:t>8.0%</a:t>
+                      </a:r>
+                      <a:endParaRPr lang="en-US" sz="900" dirty="0">
+                        <a:latin typeface="Calibri" charset="0"/>
+                        <a:ea typeface="Calibri" charset="0"/>
+                        <a:cs typeface="Calibri" charset="0"/>
+                      </a:endParaRPr>
+                    </a:p>
+                  </a:txBody>
+                  <a:tcPr marL="50800" marR="50800" marT="12700" marB="12700" anchor="ctr">
+                    <a:lnL w="12700" cap="flat" cmpd="sng" algn="ctr">
+                      <a:solidFill>
+                        <a:srgbClr val="E3DFD3"/>
+                      </a:solidFill>
+                      <a:prstDash val="solid"/>
+                      <a:round/>
+                      <a:headEnd type="none" w="med" len="med"/>
+                      <a:tailEnd type="none" w="med" len="med"/>
+                    </a:lnL>
+                    <a:lnR w="12700" cap="flat" cmpd="sng" algn="ctr">
+                      <a:solidFill>
+                        <a:srgbClr val="E3DFD3"/>
+                      </a:solidFill>
+                      <a:prstDash val="solid"/>
+                      <a:round/>
+                      <a:headEnd type="none" w="med" len="med"/>
+                      <a:tailEnd type="none" w="med" len="med"/>
+                    </a:lnR>
+                    <a:lnT w="12700" cap="flat" cmpd="sng" algn="ctr">
+                      <a:solidFill>
+                        <a:srgbClr val="E3DFD3"/>
+                      </a:solidFill>
+                      <a:prstDash val="solid"/>
+                      <a:round/>
+                      <a:headEnd type="none" w="med" len="med"/>
+                      <a:tailEnd type="none" w="med" len="med"/>
+                    </a:lnT>
+                    <a:lnB w="12700" cap="flat" cmpd="sng" algn="ctr">
+                      <a:solidFill>
+                        <a:srgbClr val="E3DFD3"/>
+                      </a:solidFill>
+                      <a:prstDash val="solid"/>
+                      <a:round/>
+                      <a:headEnd type="none" w="med" len="med"/>
+                      <a:tailEnd type="none" w="med" len="med"/>
+                    </a:lnB>
+                    <a:solidFill>
+                      <a:srgbClr val="FFFFFF"/>
+                    </a:solidFill>
+                  </a:tcPr>
+                </a:tc>
+              </a:tr>
+              <a:tr h="155448">
+                <a:tc>
+                  <a:txBody>
+                    <a:bodyPr/>
+                    <a:lstStyle/>
+                    <a:p>
+                      <a:pPr algn="l" indent="0" marL="0">
+                        <a:buNone/>
+                      </a:pPr>
+                      <a:r>
+                        <a:rPr lang="en-US" sz="900" dirty="0">
+                          <a:solidFill>
+                            <a:srgbClr val="0B1B2B"/>
+                          </a:solidFill>
+                          <a:latin typeface="Calibri" pitchFamily="34" charset="0"/>
+                          <a:ea typeface="Calibri" pitchFamily="34" charset="-122"/>
+                          <a:cs typeface="Calibri" pitchFamily="34" charset="-120"/>
+                        </a:rPr>
+                        <a:t>Liquidity</a:t>
+                      </a:r>
+                      <a:endParaRPr lang="en-US" sz="900" dirty="0">
+                        <a:latin typeface="Calibri" charset="0"/>
+                        <a:ea typeface="Calibri" charset="0"/>
+                        <a:cs typeface="Calibri" charset="0"/>
+                      </a:endParaRPr>
+                    </a:p>
+                  </a:txBody>
+                  <a:tcPr marL="50800" marR="50800" marT="12700" marB="12700" anchor="ctr">
+                    <a:lnL w="12700" cap="flat" cmpd="sng" algn="ctr">
+                      <a:solidFill>
+                        <a:srgbClr val="E3DFD3"/>
+                      </a:solidFill>
+                      <a:prstDash val="solid"/>
+                      <a:round/>
+                      <a:headEnd type="none" w="med" len="med"/>
+                      <a:tailEnd type="none" w="med" len="med"/>
+                    </a:lnL>
+                    <a:lnR w="12700" cap="flat" cmpd="sng" algn="ctr">
+                      <a:solidFill>
+                        <a:srgbClr val="E3DFD3"/>
+                      </a:solidFill>
+                      <a:prstDash val="solid"/>
+                      <a:round/>
+                      <a:headEnd type="none" w="med" len="med"/>
+                      <a:tailEnd type="none" w="med" len="med"/>
+                    </a:lnR>
+                    <a:lnT w="12700" cap="flat" cmpd="sng" algn="ctr">
+                      <a:solidFill>
+                        <a:srgbClr val="E3DFD3"/>
+                      </a:solidFill>
+                      <a:prstDash val="solid"/>
+                      <a:round/>
+                      <a:headEnd type="none" w="med" len="med"/>
+                      <a:tailEnd type="none" w="med" len="med"/>
+                    </a:lnT>
+                    <a:lnB w="12700" cap="flat" cmpd="sng" algn="ctr">
+                      <a:solidFill>
+                        <a:srgbClr val="E3DFD3"/>
+                      </a:solidFill>
+                      <a:prstDash val="solid"/>
+                      <a:round/>
+                      <a:headEnd type="none" w="med" len="med"/>
+                      <a:tailEnd type="none" w="med" len="med"/>
+                    </a:lnB>
+                    <a:solidFill>
+                      <a:srgbClr val="F6F3EC"/>
+                    </a:solidFill>
+                  </a:tcPr>
+                </a:tc>
+                <a:tc>
+                  <a:txBody>
+                    <a:bodyPr/>
+                    <a:lstStyle/>
+                    <a:p>
+                      <a:pPr algn="l" indent="0" marL="0">
+                        <a:buNone/>
+                      </a:pPr>
+                      <a:r>
+                        <a:rPr lang="en-US" sz="900" dirty="0">
+                          <a:solidFill>
+                            <a:srgbClr val="0B1B2B"/>
+                          </a:solidFill>
+                          <a:latin typeface="Calibri" pitchFamily="34" charset="0"/>
+                          <a:ea typeface="Calibri" pitchFamily="34" charset="-122"/>
+                          <a:cs typeface="Calibri" pitchFamily="34" charset="-120"/>
+                        </a:rPr>
+                        <a:t>10%</a:t>
+                      </a:r>
+                      <a:endParaRPr lang="en-US" sz="900" dirty="0">
+                        <a:latin typeface="Calibri" charset="0"/>
+                        <a:ea typeface="Calibri" charset="0"/>
+                        <a:cs typeface="Calibri" charset="0"/>
+                      </a:endParaRPr>
+                    </a:p>
+                  </a:txBody>
+                  <a:tcPr marL="50800" marR="50800" marT="12700" marB="12700" anchor="ctr">
+                    <a:lnL w="12700" cap="flat" cmpd="sng" algn="ctr">
+                      <a:solidFill>
+                        <a:srgbClr val="E3DFD3"/>
+                      </a:solidFill>
+                      <a:prstDash val="solid"/>
+                      <a:round/>
+                      <a:headEnd type="none" w="med" len="med"/>
+                      <a:tailEnd type="none" w="med" len="med"/>
+                    </a:lnL>
+                    <a:lnR w="12700" cap="flat" cmpd="sng" algn="ctr">
+                      <a:solidFill>
+                        <a:srgbClr val="E3DFD3"/>
+                      </a:solidFill>
+                      <a:prstDash val="solid"/>
+                      <a:round/>
+                      <a:headEnd type="none" w="med" len="med"/>
+                      <a:tailEnd type="none" w="med" len="med"/>
+                    </a:lnR>
+                    <a:lnT w="12700" cap="flat" cmpd="sng" algn="ctr">
+                      <a:solidFill>
+                        <a:srgbClr val="E3DFD3"/>
+                      </a:solidFill>
+                      <a:prstDash val="solid"/>
+                      <a:round/>
+                      <a:headEnd type="none" w="med" len="med"/>
+                      <a:tailEnd type="none" w="med" len="med"/>
+                    </a:lnT>
+                    <a:lnB w="12700" cap="flat" cmpd="sng" algn="ctr">
+                      <a:solidFill>
+                        <a:srgbClr val="E3DFD3"/>
+                      </a:solidFill>
+                      <a:prstDash val="solid"/>
+                      <a:round/>
+                      <a:headEnd type="none" w="med" len="med"/>
+                      <a:tailEnd type="none" w="med" len="med"/>
+                    </a:lnB>
+                    <a:solidFill>
+                      <a:srgbClr val="F6F3EC"/>
+                    </a:solidFill>
+                  </a:tcPr>
+                </a:tc>
+                <a:tc>
+                  <a:txBody>
+                    <a:bodyPr/>
+                    <a:lstStyle/>
+                    <a:p>
+                      <a:pPr algn="l" indent="0" marL="0">
+                        <a:buNone/>
+                      </a:pPr>
+                      <a:r>
+                        <a:rPr lang="en-US" sz="900" dirty="0">
+                          <a:solidFill>
+                            <a:srgbClr val="0B1B2B"/>
+                          </a:solidFill>
+                          <a:latin typeface="Calibri" pitchFamily="34" charset="0"/>
+                          <a:ea typeface="Calibri" pitchFamily="34" charset="-122"/>
+                          <a:cs typeface="Calibri" pitchFamily="34" charset="-120"/>
+                        </a:rPr>
+                        <a:t>4.0%</a:t>
+                      </a:r>
+                      <a:endParaRPr lang="en-US" sz="900" dirty="0">
+                        <a:latin typeface="Calibri" charset="0"/>
+                        <a:ea typeface="Calibri" charset="0"/>
+                        <a:cs typeface="Calibri" charset="0"/>
+                      </a:endParaRPr>
+                    </a:p>
+                  </a:txBody>
+                  <a:tcPr marL="50800" marR="50800" marT="12700" marB="12700" anchor="ctr">
+                    <a:lnL w="12700" cap="flat" cmpd="sng" algn="ctr">
+                      <a:solidFill>
+                        <a:srgbClr val="E3DFD3"/>
+                      </a:solidFill>
+                      <a:prstDash val="solid"/>
+                      <a:round/>
+                      <a:headEnd type="none" w="med" len="med"/>
+                      <a:tailEnd type="none" w="med" len="med"/>
+                    </a:lnL>
+                    <a:lnR w="12700" cap="flat" cmpd="sng" algn="ctr">
+                      <a:solidFill>
+                        <a:srgbClr val="E3DFD3"/>
+                      </a:solidFill>
+                      <a:prstDash val="solid"/>
+                      <a:round/>
+                      <a:headEnd type="none" w="med" len="med"/>
+                      <a:tailEnd type="none" w="med" len="med"/>
+                    </a:lnR>
+                    <a:lnT w="12700" cap="flat" cmpd="sng" algn="ctr">
+                      <a:solidFill>
+                        <a:srgbClr val="E3DFD3"/>
+                      </a:solidFill>
+                      <a:prstDash val="solid"/>
+                      <a:round/>
+                      <a:headEnd type="none" w="med" len="med"/>
+                      <a:tailEnd type="none" w="med" len="med"/>
+                    </a:lnT>
+                    <a:lnB w="12700" cap="flat" cmpd="sng" algn="ctr">
+                      <a:solidFill>
+                        <a:srgbClr val="E3DFD3"/>
+                      </a:solidFill>
+                      <a:prstDash val="solid"/>
+                      <a:round/>
+                      <a:headEnd type="none" w="med" len="med"/>
+                      <a:tailEnd type="none" w="med" len="med"/>
+                    </a:lnB>
+                    <a:solidFill>
+                      <a:srgbClr val="F6F3EC"/>
+                    </a:solidFill>
+                  </a:tcPr>
+                </a:tc>
+                <a:tc>
+                  <a:txBody>
+                    <a:bodyPr/>
+                    <a:lstStyle/>
+                    <a:p>
+                      <a:pPr algn="l" indent="0" marL="0">
+                        <a:buNone/>
+                      </a:pPr>
+                      <a:r>
+                        <a:rPr lang="en-US" sz="900" dirty="0">
+                          <a:solidFill>
+                            <a:srgbClr val="0B1B2B"/>
+                          </a:solidFill>
+                          <a:latin typeface="Calibri" pitchFamily="34" charset="0"/>
+                          <a:ea typeface="Calibri" pitchFamily="34" charset="-122"/>
+                          <a:cs typeface="Calibri" pitchFamily="34" charset="-120"/>
+                        </a:rPr>
+                        <a:t>4.0%</a:t>
+                      </a:r>
+                      <a:endParaRPr lang="en-US" sz="900" dirty="0">
+                        <a:latin typeface="Calibri" charset="0"/>
+                        <a:ea typeface="Calibri" charset="0"/>
+                        <a:cs typeface="Calibri" charset="0"/>
+                      </a:endParaRPr>
+                    </a:p>
+                  </a:txBody>
+                  <a:tcPr marL="50800" marR="50800" marT="12700" marB="12700" anchor="ctr">
+                    <a:lnL w="12700" cap="flat" cmpd="sng" algn="ctr">
+                      <a:solidFill>
+                        <a:srgbClr val="E3DFD3"/>
+                      </a:solidFill>
+                      <a:prstDash val="solid"/>
+                      <a:round/>
+                      <a:headEnd type="none" w="med" len="med"/>
+                      <a:tailEnd type="none" w="med" len="med"/>
+                    </a:lnL>
+                    <a:lnR w="12700" cap="flat" cmpd="sng" algn="ctr">
+                      <a:solidFill>
+                        <a:srgbClr val="E3DFD3"/>
+                      </a:solidFill>
+                      <a:prstDash val="solid"/>
+                      <a:round/>
+                      <a:headEnd type="none" w="med" len="med"/>
+                      <a:tailEnd type="none" w="med" len="med"/>
+                    </a:lnR>
+                    <a:lnT w="12700" cap="flat" cmpd="sng" algn="ctr">
+                      <a:solidFill>
+                        <a:srgbClr val="E3DFD3"/>
+                      </a:solidFill>
+                      <a:prstDash val="solid"/>
+                      <a:round/>
+                      <a:headEnd type="none" w="med" len="med"/>
+                      <a:tailEnd type="none" w="med" len="med"/>
+                    </a:lnT>
+                    <a:lnB w="12700" cap="flat" cmpd="sng" algn="ctr">
+                      <a:solidFill>
+                        <a:srgbClr val="E3DFD3"/>
+                      </a:solidFill>
+                      <a:prstDash val="solid"/>
+                      <a:round/>
+                      <a:headEnd type="none" w="med" len="med"/>
+                      <a:tailEnd type="none" w="med" len="med"/>
+                    </a:lnB>
+                    <a:solidFill>
+                      <a:srgbClr val="F6F3EC"/>
+                    </a:solidFill>
+                  </a:tcPr>
+                </a:tc>
+              </a:tr>
+            </a:tbl>
+          </a:graphicData>
+        </a:graphic>
+      </p:graphicFrame>
+      <p:sp>
+        <p:nvSpPr>
+          <p:cNvPr id="17" name="Text 11"/>
+          <p:cNvSpPr txBox="1"/>
+          <p:nvPr/>
+        </p:nvSpPr>
+        <p:spPr>
+          <a:xfrm>
+            <a:off x="457200" y="6528816"/>
+            <a:ext cx="7315200" cy="256032"/>
           </a:xfrm>
           <a:prstGeom prst="rect">
             <a:avLst/>
@@ -11117,7 +12501,7 @@
               <a:buNone/>
             </a:pPr>
             <a:r>
-              <a:rPr lang="en-US" sz="900" i="1" dirty="0">
+              <a:rPr lang="en-US" sz="850" dirty="0">
                 <a:solidFill>
                   <a:srgbClr val="8C93A0"/>
                 </a:solidFill>
@@ -11125,45 +12509,6 @@
                 <a:ea typeface="Calibri" pitchFamily="34" charset="-122"/>
                 <a:cs typeface="Calibri" pitchFamily="34" charset="-120"/>
               </a:rPr>
-              <a:t>Illustrative long-run assumptions: Equities 9.0% total return (2.5% yield); Bonds &amp; Credit 5.0% (4.5% yield); Alternatives 8.0% (4.0% yield); Liquidity 4.0%.</a:t>
-            </a:r>
-            <a:endParaRPr lang="en-US" sz="900" dirty="0"/>
-          </a:p>
-        </p:txBody>
-      </p:sp>
-      <p:sp>
-        <p:nvSpPr>
-          <p:cNvPr id="17" name="Text 12"/>
-          <p:cNvSpPr txBox="1"/>
-          <p:nvPr/>
-        </p:nvSpPr>
-        <p:spPr>
-          <a:xfrm>
-            <a:off x="457200" y="6528816"/>
-            <a:ext cx="7315200" cy="256032"/>
-          </a:xfrm>
-          <a:prstGeom prst="rect">
-            <a:avLst/>
-          </a:prstGeom>
-          <a:noFill/>
-          <a:ln/>
-        </p:spPr>
-        <p:txBody>
-          <a:bodyPr wrap="square" rtlCol="0" anchor="ctr"/>
-          <a:lstStyle/>
-          <a:p>
-            <a:pPr indent="0" marL="0">
-              <a:buNone/>
-            </a:pPr>
-            <a:r>
-              <a:rPr lang="en-US" sz="850" dirty="0">
-                <a:solidFill>
-                  <a:srgbClr val="8C93A0"/>
-                </a:solidFill>
-                <a:latin typeface="Calibri" pitchFamily="34" charset="0"/>
-                <a:ea typeface="Calibri" pitchFamily="34" charset="-122"/>
-                <a:cs typeface="Calibri" pitchFamily="34" charset="-120"/>
-              </a:rPr>
               <a:t>Private Wealth Advisory · Strictly Private &amp; Confidential</a:t>
             </a:r>
             <a:endParaRPr lang="en-US" sz="850" dirty="0"/>
@@ -11172,7 +12517,7 @@
       </p:sp>
       <p:sp>
         <p:nvSpPr>
-          <p:cNvPr id="18" name="Text 13"/>
+          <p:cNvPr id="18" name="Text 12"/>
           <p:cNvSpPr txBox="1"/>
           <p:nvPr/>
         </p:nvSpPr>

</xml_diff>